<commit_message>
Toán 10: gắn nhãn ĐỀ BÀI / LỜI GIẢI cho các cặp slide đã tách, sửa hình tràn mép, rút gọn tiêu đề dài
Co-Authored-By: Claude Opus 5.5 <noreply@anthropic.com>
</commit_message>
<xml_diff>
--- a/slide/Slide_TOAN10_Bai2_T5-8.pptx
+++ b/slide/Slide_TOAN10_Bai2_T5-8.pptx
@@ -3452,7 +3452,7 @@
                 </a:solidFill>
                 <a:latin typeface="Arial"/>
               </a:rPr>
-              <a:t>TẬP CON THƯỜNG DÙNG CỦA ℝ</a:t>
+              <a:t>HAI TẬP HỢP BẰNG NHAU</a:t>
             </a:r>
           </a:p>
         </p:txBody>
@@ -3531,45 +3531,21 @@
                 </a:solidFill>
                 <a:latin typeface="Calibri"/>
               </a:rPr>
-              <a:t>Toán 10 · Bài 2. Tập hợp và các phép toán trên tập hợp          12</a:t>
-            </a:r>
-          </a:p>
-        </p:txBody>
-      </p:sp>
-      <p:pic>
-        <p:nvPicPr>
-          <p:cNvPr id="6" name="Picture 5" descr="rId13.png"/>
-          <p:cNvPicPr>
-            <a:picLocks noChangeAspect="1"/>
-          </p:cNvPicPr>
-          <p:nvPr/>
-        </p:nvPicPr>
-        <p:blipFill>
-          <a:blip r:embed="rId2"/>
-          <a:stretch>
-            <a:fillRect/>
-          </a:stretch>
-        </p:blipFill>
-        <p:spPr>
-          <a:xfrm>
-            <a:off x="3861849" y="1417320"/>
-            <a:ext cx="4437821" cy="4343400"/>
-          </a:xfrm>
-          <a:prstGeom prst="rect">
-            <a:avLst/>
-          </a:prstGeom>
-        </p:spPr>
-      </p:pic>
-      <p:sp>
-        <p:nvSpPr>
-          <p:cNvPr id="7" name="TextBox 6"/>
+              <a:t>Toán 10 · Bài 2. Tập hợp và các phép toán trên tập hợp          10</a:t>
+            </a:r>
+          </a:p>
+        </p:txBody>
+      </p:sp>
+      <p:sp>
+        <p:nvSpPr>
+          <p:cNvPr id="6" name="TextBox 5"/>
           <p:cNvSpPr txBox="1"/>
           <p:nvPr/>
         </p:nvSpPr>
         <p:spPr>
           <a:xfrm>
-            <a:off x="731520" y="5806440"/>
-            <a:ext cx="10698480" cy="457200"/>
+            <a:off x="731520" y="1508760"/>
+            <a:ext cx="10789920" cy="2267712"/>
           </a:xfrm>
           <a:prstGeom prst="rect">
             <a:avLst/>
@@ -3582,19 +3558,169 @@
           </a:bodyPr>
           <a:lstStyle/>
           <a:p>
-            <a:pPr algn="ctr">
+            <a:pPr algn="l">
               <a:spcAft>
                 <a:spcPts val="1000"/>
               </a:spcAft>
             </a:pPr>
             <a:r>
-              <a:rPr sz="2200" b="1">
+              <a:rPr sz="2400" b="1">
                 <a:solidFill>
                   <a:srgbClr val="1E40AF"/>
                 </a:solidFill>
                 <a:latin typeface="Calibri"/>
               </a:rPr>
-              <a:t>( ): không lấy đầu mút;   [ ]: lấy đầu mút</a:t>
+              <a:t>Hai tập có cùng các phần tử</a:t>
+            </a:r>
+          </a:p>
+          <a:p>
+            <a:pPr algn="l" marL="365760" indent="-365760">
+              <a:spcAft>
+                <a:spcPts val="1000"/>
+              </a:spcAft>
+              <a:buClr>
+                <a:srgbClr val="1E40AF"/>
+              </a:buClr>
+              <a:buFont typeface="Arial"/>
+              <a:buChar char="•"/>
+            </a:pPr>
+            <a:r>
+              <a:rPr sz="2400">
+                <a:solidFill>
+                  <a:srgbClr val="1E293B"/>
+                </a:solidFill>
+                <a:latin typeface="Calibri"/>
+              </a:rPr>
+              <a:t>C: bội chung của 2 và 3, nhỏ hơn 30</a:t>
+            </a:r>
+          </a:p>
+          <a:p>
+            <a:pPr algn="l" marL="365760" indent="-365760">
+              <a:spcAft>
+                <a:spcPts val="1000"/>
+              </a:spcAft>
+              <a:buClr>
+                <a:srgbClr val="1E40AF"/>
+              </a:buClr>
+              <a:buFont typeface="Arial"/>
+              <a:buChar char="•"/>
+            </a:pPr>
+            <a:r>
+              <a:rPr sz="2400">
+                <a:solidFill>
+                  <a:srgbClr val="1E293B"/>
+                </a:solidFill>
+                <a:latin typeface="Calibri"/>
+              </a:rPr>
+              <a:t>D: bội của 6, nhỏ hơn 30</a:t>
+            </a:r>
+          </a:p>
+          <a:p>
+            <a:pPr algn="l" marL="365760" indent="-365760">
+              <a:spcAft>
+                <a:spcPts val="1000"/>
+              </a:spcAft>
+              <a:buClr>
+                <a:srgbClr val="1E40AF"/>
+              </a:buClr>
+              <a:buFont typeface="Arial"/>
+              <a:buChar char="•"/>
+            </a:pPr>
+            <a:r>
+              <a:rPr sz="2400">
+                <a:solidFill>
+                  <a:srgbClr val="1E293B"/>
+                </a:solidFill>
+                <a:latin typeface="Calibri"/>
+              </a:rPr>
+              <a:t>C = D = {0; 6; 12; 18; 24}</a:t>
+            </a:r>
+          </a:p>
+        </p:txBody>
+      </p:sp>
+      <p:sp>
+        <p:nvSpPr>
+          <p:cNvPr id="7" name="Rounded Rectangle 6"/>
+          <p:cNvSpPr/>
+          <p:nvPr/>
+        </p:nvSpPr>
+        <p:spPr>
+          <a:xfrm>
+            <a:off x="731520" y="3913632"/>
+            <a:ext cx="8686800" cy="685800"/>
+          </a:xfrm>
+          <a:prstGeom prst="roundRect">
+            <a:avLst>
+              <a:gd name="adj" fmla="val 8000"/>
+            </a:avLst>
+          </a:prstGeom>
+          <a:solidFill>
+            <a:srgbClr val="FEF2F2"/>
+          </a:solidFill>
+          <a:ln w="19050">
+            <a:solidFill>
+              <a:srgbClr val="991B1B"/>
+            </a:solidFill>
+          </a:ln>
+          <a:effectLst/>
+        </p:spPr>
+        <p:style>
+          <a:lnRef idx="1">
+            <a:schemeClr val="accent1"/>
+          </a:lnRef>
+          <a:fillRef idx="3">
+            <a:schemeClr val="accent1"/>
+          </a:fillRef>
+          <a:effectRef idx="2">
+            <a:schemeClr val="accent1"/>
+          </a:effectRef>
+          <a:fontRef idx="minor">
+            <a:schemeClr val="lt1"/>
+          </a:fontRef>
+        </p:style>
+        <p:txBody>
+          <a:bodyPr rtlCol="0" anchor="ctr"/>
+          <a:lstStyle/>
+          <a:p>
+            <a:pPr algn="ctr"/>
+          </a:p>
+        </p:txBody>
+      </p:sp>
+      <p:sp>
+        <p:nvSpPr>
+          <p:cNvPr id="8" name="TextBox 7"/>
+          <p:cNvSpPr txBox="1"/>
+          <p:nvPr/>
+        </p:nvSpPr>
+        <p:spPr>
+          <a:xfrm>
+            <a:off x="914400" y="3913632"/>
+            <a:ext cx="8321040" cy="685800"/>
+          </a:xfrm>
+          <a:prstGeom prst="rect">
+            <a:avLst/>
+          </a:prstGeom>
+          <a:noFill/>
+        </p:spPr>
+        <p:txBody>
+          <a:bodyPr wrap="square" anchor="ctr">
+            <a:spAutoFit/>
+          </a:bodyPr>
+          <a:lstStyle/>
+          <a:p>
+            <a:pPr algn="l">
+              <a:spcAft>
+                <a:spcPts val="400"/>
+              </a:spcAft>
+            </a:pPr>
+            <a:r>
+              <a:rPr sz="2400" b="1">
+                <a:solidFill>
+                  <a:srgbClr val="991B1B"/>
+                </a:solidFill>
+                <a:latin typeface="Calibri"/>
+              </a:rPr>
+              <a:t>S ⊂ T và T ⊂ S  ⇒  S = T</a:t>
             </a:r>
           </a:p>
         </p:txBody>
@@ -3698,7 +3824,7 @@
                 </a:solidFill>
                 <a:latin typeface="Arial"/>
               </a:rPr>
-              <a:t>VÍ DỤ 5: KHOẢNG, ĐOẠN</a:t>
+              <a:t>3. CÁC TẬP HỢP SỐ</a:t>
             </a:r>
           </a:p>
         </p:txBody>
@@ -3777,7 +3903,7 @@
                 </a:solidFill>
                 <a:latin typeface="Calibri"/>
               </a:rPr>
-              <a:t>Toán 10 · Bài 2. Tập hợp và các phép toán trên tập hợp          13</a:t>
+              <a:t>Toán 10 · Bài 2. Tập hợp và các phép toán trên tập hợp          11</a:t>
             </a:r>
           </a:p>
         </p:txBody>
@@ -3791,7 +3917,7 @@
         <p:spPr>
           <a:xfrm>
             <a:off x="731520" y="1508760"/>
-            <a:ext cx="10789920" cy="1700784"/>
+            <a:ext cx="6400800" cy="2267712"/>
           </a:xfrm>
           <a:prstGeom prst="rect">
             <a:avLst/>
@@ -3821,7 +3947,7 @@
                 </a:solidFill>
                 <a:latin typeface="Calibri"/>
               </a:rPr>
-              <a:t>Viết dạng khoảng, đoạn; biểu diễn trục số:</a:t>
+              <a:t>ℕ: số tự nhiên;  ℤ: số nguyên</a:t>
             </a:r>
           </a:p>
           <a:p>
@@ -3842,7 +3968,7 @@
                 </a:solidFill>
                 <a:latin typeface="Calibri"/>
               </a:rPr>
-              <a:t>C = {x ∈ ℝ | 2 ≤ x ≤ 7}</a:t>
+              <a:t>ℚ: số viết được dạng a/b</a:t>
             </a:r>
           </a:p>
           <a:p>
@@ -3863,11 +3989,143 @@
                 </a:solidFill>
                 <a:latin typeface="Calibri"/>
               </a:rPr>
-              <a:t>D = {x ∈ ℝ | x &lt; 2}</a:t>
-            </a:r>
-          </a:p>
-        </p:txBody>
-      </p:sp>
+              <a:t>ℝ: gồm số hữu tỉ và vô tỉ</a:t>
+            </a:r>
+          </a:p>
+          <a:p>
+            <a:pPr algn="l" marL="365760" indent="-365760">
+              <a:spcAft>
+                <a:spcPts val="1000"/>
+              </a:spcAft>
+              <a:buClr>
+                <a:srgbClr val="1E40AF"/>
+              </a:buClr>
+              <a:buFont typeface="Arial"/>
+              <a:buChar char="•"/>
+            </a:pPr>
+            <a:r>
+              <a:rPr sz="2400">
+                <a:solidFill>
+                  <a:srgbClr val="1E293B"/>
+                </a:solidFill>
+                <a:latin typeface="Calibri"/>
+              </a:rPr>
+              <a:t>√2 ∈ ℝ nhưng √2 ∉ ℚ</a:t>
+            </a:r>
+          </a:p>
+        </p:txBody>
+      </p:sp>
+      <p:sp>
+        <p:nvSpPr>
+          <p:cNvPr id="7" name="Rounded Rectangle 6"/>
+          <p:cNvSpPr/>
+          <p:nvPr/>
+        </p:nvSpPr>
+        <p:spPr>
+          <a:xfrm>
+            <a:off x="731520" y="3913632"/>
+            <a:ext cx="6400800" cy="685800"/>
+          </a:xfrm>
+          <a:prstGeom prst="roundRect">
+            <a:avLst>
+              <a:gd name="adj" fmla="val 8000"/>
+            </a:avLst>
+          </a:prstGeom>
+          <a:solidFill>
+            <a:srgbClr val="FEF2F2"/>
+          </a:solidFill>
+          <a:ln w="19050">
+            <a:solidFill>
+              <a:srgbClr val="991B1B"/>
+            </a:solidFill>
+          </a:ln>
+          <a:effectLst/>
+        </p:spPr>
+        <p:style>
+          <a:lnRef idx="1">
+            <a:schemeClr val="accent1"/>
+          </a:lnRef>
+          <a:fillRef idx="3">
+            <a:schemeClr val="accent1"/>
+          </a:fillRef>
+          <a:effectRef idx="2">
+            <a:schemeClr val="accent1"/>
+          </a:effectRef>
+          <a:fontRef idx="minor">
+            <a:schemeClr val="lt1"/>
+          </a:fontRef>
+        </p:style>
+        <p:txBody>
+          <a:bodyPr rtlCol="0" anchor="ctr"/>
+          <a:lstStyle/>
+          <a:p>
+            <a:pPr algn="ctr"/>
+          </a:p>
+        </p:txBody>
+      </p:sp>
+      <p:sp>
+        <p:nvSpPr>
+          <p:cNvPr id="8" name="TextBox 7"/>
+          <p:cNvSpPr txBox="1"/>
+          <p:nvPr/>
+        </p:nvSpPr>
+        <p:spPr>
+          <a:xfrm>
+            <a:off x="914400" y="3913632"/>
+            <a:ext cx="6035040" cy="685800"/>
+          </a:xfrm>
+          <a:prstGeom prst="rect">
+            <a:avLst/>
+          </a:prstGeom>
+          <a:noFill/>
+        </p:spPr>
+        <p:txBody>
+          <a:bodyPr wrap="square" anchor="ctr">
+            <a:spAutoFit/>
+          </a:bodyPr>
+          <a:lstStyle/>
+          <a:p>
+            <a:pPr algn="l">
+              <a:spcAft>
+                <a:spcPts val="400"/>
+              </a:spcAft>
+            </a:pPr>
+            <a:r>
+              <a:rPr sz="2400" b="1">
+                <a:solidFill>
+                  <a:srgbClr val="991B1B"/>
+                </a:solidFill>
+                <a:latin typeface="Calibri"/>
+              </a:rPr>
+              <a:t>ℕ ⊂ ℤ ⊂ ℚ ⊂ ℝ</a:t>
+            </a:r>
+          </a:p>
+        </p:txBody>
+      </p:sp>
+      <p:pic>
+        <p:nvPicPr>
+          <p:cNvPr id="9" name="Picture 8" descr="rId12.png"/>
+          <p:cNvPicPr>
+            <a:picLocks noChangeAspect="1"/>
+          </p:cNvPicPr>
+          <p:nvPr/>
+        </p:nvPicPr>
+        <p:blipFill>
+          <a:blip r:embed="rId2"/>
+          <a:stretch>
+            <a:fillRect/>
+          </a:stretch>
+        </p:blipFill>
+        <p:spPr>
+          <a:xfrm>
+            <a:off x="7406640" y="1770380"/>
+            <a:ext cx="4389120" cy="4094480"/>
+          </a:xfrm>
+          <a:prstGeom prst="rect">
+            <a:avLst/>
+          </a:prstGeom>
+        </p:spPr>
+      </p:pic>
     </p:spTree>
   </p:cSld>
   <p:clrMapOvr>
@@ -3967,7 +4225,7 @@
                 </a:solidFill>
                 <a:latin typeface="Arial"/>
               </a:rPr>
-              <a:t>4. GIAO CỦA HAI TẬP HỢP</a:t>
+              <a:t>TẬP CON THƯỜNG DÙNG CỦA ℝ</a:t>
             </a:r>
           </a:p>
         </p:txBody>
@@ -4046,187 +4304,14 @@
                 </a:solidFill>
                 <a:latin typeface="Calibri"/>
               </a:rPr>
-              <a:t>Toán 10 · Bài 2. Tập hợp và các phép toán trên tập hợp          15</a:t>
-            </a:r>
-          </a:p>
-        </p:txBody>
-      </p:sp>
-      <p:sp>
-        <p:nvSpPr>
-          <p:cNvPr id="6" name="TextBox 5"/>
-          <p:cNvSpPr txBox="1"/>
-          <p:nvPr/>
-        </p:nvSpPr>
-        <p:spPr>
-          <a:xfrm>
-            <a:off x="731520" y="1508760"/>
-            <a:ext cx="6400800" cy="1700784"/>
-          </a:xfrm>
-          <a:prstGeom prst="rect">
-            <a:avLst/>
-          </a:prstGeom>
-          <a:noFill/>
-        </p:spPr>
-        <p:txBody>
-          <a:bodyPr wrap="square" anchor="t">
-            <a:spAutoFit/>
-          </a:bodyPr>
-          <a:lstStyle/>
-          <a:p>
-            <a:pPr algn="l" marL="365760" indent="-365760">
-              <a:spcAft>
-                <a:spcPts val="1000"/>
-              </a:spcAft>
-              <a:buClr>
-                <a:srgbClr val="1E40AF"/>
-              </a:buClr>
-              <a:buFont typeface="Arial"/>
-              <a:buChar char="•"/>
-            </a:pPr>
-            <a:r>
-              <a:rPr sz="2400">
-                <a:solidFill>
-                  <a:srgbClr val="1E293B"/>
-                </a:solidFill>
-                <a:latin typeface="Calibri"/>
-              </a:rPr>
-              <a:t>Phần tử thuộc cả S và T</a:t>
-            </a:r>
-          </a:p>
-          <a:p>
-            <a:pPr algn="l" marL="365760" indent="-365760">
-              <a:spcAft>
-                <a:spcPts val="1000"/>
-              </a:spcAft>
-              <a:buClr>
-                <a:srgbClr val="1E40AF"/>
-              </a:buClr>
-              <a:buFont typeface="Arial"/>
-              <a:buChar char="•"/>
-            </a:pPr>
-            <a:r>
-              <a:rPr sz="2400">
-                <a:solidFill>
-                  <a:srgbClr val="1E293B"/>
-                </a:solidFill>
-                <a:latin typeface="Calibri"/>
-              </a:rPr>
-              <a:t>{4; 7; 27} ∩ {2; 4; 9; 27; 36} = {4; 27}</a:t>
-            </a:r>
-          </a:p>
-          <a:p>
-            <a:pPr algn="l" marL="365760" indent="-365760">
-              <a:spcAft>
-                <a:spcPts val="1000"/>
-              </a:spcAft>
-              <a:buClr>
-                <a:srgbClr val="1E40AF"/>
-              </a:buClr>
-              <a:buFont typeface="Arial"/>
-              <a:buChar char="•"/>
-            </a:pPr>
-            <a:r>
-              <a:rPr sz="2400">
-                <a:solidFill>
-                  <a:srgbClr val="1E293B"/>
-                </a:solidFill>
-                <a:latin typeface="Calibri"/>
-              </a:rPr>
-              <a:t>[1; +∞) ∩ (−∞; 3] = [1; 3]</a:t>
-            </a:r>
-          </a:p>
-        </p:txBody>
-      </p:sp>
-      <p:sp>
-        <p:nvSpPr>
-          <p:cNvPr id="7" name="Rounded Rectangle 6"/>
-          <p:cNvSpPr/>
-          <p:nvPr/>
-        </p:nvSpPr>
-        <p:spPr>
-          <a:xfrm>
-            <a:off x="731520" y="3346704"/>
-            <a:ext cx="6400800" cy="685800"/>
-          </a:xfrm>
-          <a:prstGeom prst="roundRect">
-            <a:avLst>
-              <a:gd name="adj" fmla="val 8000"/>
-            </a:avLst>
-          </a:prstGeom>
-          <a:solidFill>
-            <a:srgbClr val="FEF2F2"/>
-          </a:solidFill>
-          <a:ln w="19050">
-            <a:solidFill>
-              <a:srgbClr val="991B1B"/>
-            </a:solidFill>
-          </a:ln>
-          <a:effectLst/>
-        </p:spPr>
-        <p:style>
-          <a:lnRef idx="1">
-            <a:schemeClr val="accent1"/>
-          </a:lnRef>
-          <a:fillRef idx="3">
-            <a:schemeClr val="accent1"/>
-          </a:fillRef>
-          <a:effectRef idx="2">
-            <a:schemeClr val="accent1"/>
-          </a:effectRef>
-          <a:fontRef idx="minor">
-            <a:schemeClr val="lt1"/>
-          </a:fontRef>
-        </p:style>
-        <p:txBody>
-          <a:bodyPr rtlCol="0" anchor="ctr"/>
-          <a:lstStyle/>
-          <a:p>
-            <a:pPr algn="ctr"/>
-          </a:p>
-        </p:txBody>
-      </p:sp>
-      <p:sp>
-        <p:nvSpPr>
-          <p:cNvPr id="8" name="TextBox 7"/>
-          <p:cNvSpPr txBox="1"/>
-          <p:nvPr/>
-        </p:nvSpPr>
-        <p:spPr>
-          <a:xfrm>
-            <a:off x="914400" y="3346704"/>
-            <a:ext cx="6035040" cy="685800"/>
-          </a:xfrm>
-          <a:prstGeom prst="rect">
-            <a:avLst/>
-          </a:prstGeom>
-          <a:noFill/>
-        </p:spPr>
-        <p:txBody>
-          <a:bodyPr wrap="square" anchor="ctr">
-            <a:spAutoFit/>
-          </a:bodyPr>
-          <a:lstStyle/>
-          <a:p>
-            <a:pPr algn="l">
-              <a:spcAft>
-                <a:spcPts val="400"/>
-              </a:spcAft>
-            </a:pPr>
-            <a:r>
-              <a:rPr sz="2400" b="1">
-                <a:solidFill>
-                  <a:srgbClr val="991B1B"/>
-                </a:solidFill>
-                <a:latin typeface="Calibri"/>
-              </a:rPr>
-              <a:t>S ∩ T = {x | x ∈ S và x ∈ T}</a:t>
+              <a:t>Toán 10 · Bài 2. Tập hợp và các phép toán trên tập hợp          12</a:t>
             </a:r>
           </a:p>
         </p:txBody>
       </p:sp>
       <p:pic>
         <p:nvPicPr>
-          <p:cNvPr id="9" name="Picture 8" descr="rId15.png"/>
+          <p:cNvPr id="6" name="Picture 5" descr="rId13.png"/>
           <p:cNvPicPr>
             <a:picLocks noChangeAspect="1"/>
           </p:cNvPicPr>
@@ -4240,14 +4325,53 @@
         </p:blipFill>
         <p:spPr>
           <a:xfrm>
-            <a:off x="7406640" y="2356536"/>
-            <a:ext cx="4389120" cy="2922168"/>
+            <a:off x="3861849" y="1417320"/>
+            <a:ext cx="4437821" cy="4343400"/>
           </a:xfrm>
           <a:prstGeom prst="rect">
             <a:avLst/>
           </a:prstGeom>
         </p:spPr>
       </p:pic>
+      <p:sp>
+        <p:nvSpPr>
+          <p:cNvPr id="7" name="TextBox 6"/>
+          <p:cNvSpPr txBox="1"/>
+          <p:nvPr/>
+        </p:nvSpPr>
+        <p:spPr>
+          <a:xfrm>
+            <a:off x="731520" y="5806440"/>
+            <a:ext cx="10698480" cy="457200"/>
+          </a:xfrm>
+          <a:prstGeom prst="rect">
+            <a:avLst/>
+          </a:prstGeom>
+          <a:noFill/>
+        </p:spPr>
+        <p:txBody>
+          <a:bodyPr wrap="square" anchor="t">
+            <a:spAutoFit/>
+          </a:bodyPr>
+          <a:lstStyle/>
+          <a:p>
+            <a:pPr algn="ctr">
+              <a:spcAft>
+                <a:spcPts val="1000"/>
+              </a:spcAft>
+            </a:pPr>
+            <a:r>
+              <a:rPr sz="2200" b="1">
+                <a:solidFill>
+                  <a:srgbClr val="1E40AF"/>
+                </a:solidFill>
+                <a:latin typeface="Calibri"/>
+              </a:rPr>
+              <a:t>( ): không lấy đầu mút;   [ ]: lấy đầu mút</a:t>
+            </a:r>
+          </a:p>
+        </p:txBody>
+      </p:sp>
     </p:spTree>
   </p:cSld>
   <p:clrMapOvr>
@@ -4327,7 +4451,7 @@
         <p:spPr>
           <a:xfrm>
             <a:off x="731520" y="274320"/>
-            <a:ext cx="10972800" cy="868680"/>
+            <a:ext cx="9848088" cy="868680"/>
           </a:xfrm>
           <a:prstGeom prst="rect">
             <a:avLst/>
@@ -4347,7 +4471,7 @@
                 </a:solidFill>
                 <a:latin typeface="Arial"/>
               </a:rPr>
-              <a:t>HỢP CỦA HAI TẬP HỢP</a:t>
+              <a:t>VÍ DỤ 5: KHOẢNG, ĐOẠN</a:t>
             </a:r>
           </a:p>
         </p:txBody>
@@ -4426,7 +4550,7 @@
                 </a:solidFill>
                 <a:latin typeface="Calibri"/>
               </a:rPr>
-              <a:t>Toán 10 · Bài 2. Tập hợp và các phép toán trên tập hợp          16</a:t>
+              <a:t>Toán 10 · Bài 2. Tập hợp và các phép toán trên tập hợp          13</a:t>
             </a:r>
           </a:p>
         </p:txBody>
@@ -4440,7 +4564,7 @@
         <p:spPr>
           <a:xfrm>
             <a:off x="731520" y="1508760"/>
-            <a:ext cx="6400800" cy="2267712"/>
+            <a:ext cx="10789920" cy="1700784"/>
           </a:xfrm>
           <a:prstGeom prst="rect">
             <a:avLst/>
@@ -4470,7 +4594,7 @@
                 </a:solidFill>
                 <a:latin typeface="Calibri"/>
               </a:rPr>
-              <a:t>Phần tử thuộc S hoặc thuộc T</a:t>
+              <a:t>Viết dạng khoảng, đoạn; biểu diễn trục số:</a:t>
             </a:r>
           </a:p>
           <a:p>
@@ -4491,7 +4615,7 @@
                 </a:solidFill>
                 <a:latin typeface="Calibri"/>
               </a:rPr>
-              <a:t>{2; 3; 4; 7} ∪ {−1; 2; 3; 4; 6}</a:t>
+              <a:t>C = {x ∈ ℝ | 2 ≤ x ≤ 7}</a:t>
             </a:r>
           </a:p>
           <a:p>
@@ -4512,28 +4636,7 @@
                 </a:solidFill>
                 <a:latin typeface="Calibri"/>
               </a:rPr>
-              <a:t>= {−1; 2; 3; 4; 6; 7}</a:t>
-            </a:r>
-          </a:p>
-          <a:p>
-            <a:pPr algn="l" marL="365760" indent="-365760">
-              <a:spcAft>
-                <a:spcPts val="1000"/>
-              </a:spcAft>
-              <a:buClr>
-                <a:srgbClr val="1E40AF"/>
-              </a:buClr>
-              <a:buFont typeface="Arial"/>
-              <a:buChar char="•"/>
-            </a:pPr>
-            <a:r>
-              <a:rPr sz="2400">
-                <a:solidFill>
-                  <a:srgbClr val="1E293B"/>
-                </a:solidFill>
-                <a:latin typeface="Calibri"/>
-              </a:rPr>
-              <a:t>(−1; 2] ∪ [0; 3] = (−1; 3]</a:t>
+              <a:t>D = {x ∈ ℝ | x &lt; 2}</a:t>
             </a:r>
           </a:p>
         </p:txBody>
@@ -4546,21 +4649,17 @@
         </p:nvSpPr>
         <p:spPr>
           <a:xfrm>
-            <a:off x="731520" y="3913632"/>
-            <a:ext cx="6400800" cy="685800"/>
+            <a:off x="10701223" y="457200"/>
+            <a:ext cx="941832" cy="457200"/>
           </a:xfrm>
           <a:prstGeom prst="roundRect">
-            <a:avLst>
-              <a:gd name="adj" fmla="val 8000"/>
-            </a:avLst>
+            <a:avLst/>
           </a:prstGeom>
           <a:solidFill>
-            <a:srgbClr val="FEF2F2"/>
+            <a:srgbClr val="1E40AF"/>
           </a:solidFill>
-          <a:ln w="19050">
-            <a:solidFill>
-              <a:srgbClr val="991B1B"/>
-            </a:solidFill>
+          <a:ln>
+            <a:noFill/>
           </a:ln>
           <a:effectLst/>
         </p:spPr>
@@ -4579,76 +4678,22 @@
           </a:fontRef>
         </p:style>
         <p:txBody>
-          <a:bodyPr rtlCol="0" anchor="ctr"/>
+          <a:bodyPr rtlCol="0" anchor="ctr" tIns="0" bIns="0"/>
           <a:lstStyle/>
           <a:p>
             <a:pPr algn="ctr"/>
-          </a:p>
-        </p:txBody>
-      </p:sp>
-      <p:sp>
-        <p:nvSpPr>
-          <p:cNvPr id="8" name="TextBox 7"/>
-          <p:cNvSpPr txBox="1"/>
-          <p:nvPr/>
-        </p:nvSpPr>
-        <p:spPr>
-          <a:xfrm>
-            <a:off x="914400" y="3913632"/>
-            <a:ext cx="6035040" cy="685800"/>
-          </a:xfrm>
-          <a:prstGeom prst="rect">
-            <a:avLst/>
-          </a:prstGeom>
-          <a:noFill/>
-        </p:spPr>
-        <p:txBody>
-          <a:bodyPr wrap="square" anchor="ctr">
-            <a:spAutoFit/>
-          </a:bodyPr>
-          <a:lstStyle/>
-          <a:p>
-            <a:pPr algn="l">
-              <a:spcAft>
-                <a:spcPts val="400"/>
-              </a:spcAft>
-            </a:pPr>
-            <a:r>
-              <a:rPr sz="2400" b="1">
-                <a:solidFill>
-                  <a:srgbClr val="991B1B"/>
-                </a:solidFill>
-                <a:latin typeface="Calibri"/>
-              </a:rPr>
-              <a:t>S ∪ T = {x | x ∈ S hoặc x ∈ T}</a:t>
-            </a:r>
-          </a:p>
-        </p:txBody>
-      </p:sp>
-      <p:pic>
-        <p:nvPicPr>
-          <p:cNvPr id="9" name="Picture 8" descr="rId17.png"/>
-          <p:cNvPicPr>
-            <a:picLocks noChangeAspect="1"/>
-          </p:cNvPicPr>
-          <p:nvPr/>
-        </p:nvPicPr>
-        <p:blipFill>
-          <a:blip r:embed="rId2"/>
-          <a:stretch>
-            <a:fillRect/>
-          </a:stretch>
-        </p:blipFill>
-        <p:spPr>
-          <a:xfrm>
-            <a:off x="7406640" y="2344641"/>
-            <a:ext cx="4389120" cy="2945958"/>
-          </a:xfrm>
-          <a:prstGeom prst="rect">
-            <a:avLst/>
-          </a:prstGeom>
-        </p:spPr>
-      </p:pic>
+            <a:r>
+              <a:rPr sz="1400" b="1">
+                <a:solidFill>
+                  <a:srgbClr val="FFFFFF"/>
+                </a:solidFill>
+                <a:latin typeface="Arial"/>
+              </a:rPr>
+              <a:t>ĐỀ BÀI</a:t>
+            </a:r>
+          </a:p>
+        </p:txBody>
+      </p:sp>
     </p:spTree>
   </p:cSld>
   <p:clrMapOvr>
@@ -4728,7 +4773,7 @@
         <p:spPr>
           <a:xfrm>
             <a:off x="731520" y="274320"/>
-            <a:ext cx="10972800" cy="868680"/>
+            <a:ext cx="9610344" cy="868680"/>
           </a:xfrm>
           <a:prstGeom prst="rect">
             <a:avLst/>
@@ -4748,7 +4793,7 @@
                 </a:solidFill>
                 <a:latin typeface="Arial"/>
               </a:rPr>
-              <a:t>TRỞ LẠI KHỞI ĐỘNG</a:t>
+              <a:t>VÍ DỤ 5: KHOẢNG, ĐOẠN</a:t>
             </a:r>
           </a:p>
         </p:txBody>
@@ -4827,45 +4872,21 @@
                 </a:solidFill>
                 <a:latin typeface="Calibri"/>
               </a:rPr>
-              <a:t>Toán 10 · Bài 2. Tập hợp và các phép toán trên tập hợp          17</a:t>
-            </a:r>
-          </a:p>
-        </p:txBody>
-      </p:sp>
-      <p:pic>
-        <p:nvPicPr>
-          <p:cNvPr id="9" name="Picture 8" descr="rId9.png"/>
-          <p:cNvPicPr>
-            <a:picLocks noChangeAspect="1"/>
-          </p:cNvPicPr>
-          <p:nvPr/>
-        </p:nvPicPr>
-        <p:blipFill>
-          <a:blip r:embed="rId2"/>
-          <a:stretch>
-            <a:fillRect/>
-          </a:stretch>
-        </p:blipFill>
-        <p:spPr>
-          <a:xfrm>
-            <a:off x="4023291" y="4169664"/>
-            <a:ext cx="4114937" cy="2048256"/>
-          </a:xfrm>
-          <a:prstGeom prst="rect">
-            <a:avLst/>
-          </a:prstGeom>
-        </p:spPr>
-      </p:pic>
-      <p:sp>
-        <p:nvSpPr>
-          <p:cNvPr id="10" name="TextBox 9"/>
+              <a:t>Toán 10 · Bài 2. Tập hợp và các phép toán trên tập hợp          14</a:t>
+            </a:r>
+          </a:p>
+        </p:txBody>
+      </p:sp>
+      <p:sp>
+        <p:nvSpPr>
+          <p:cNvPr id="6" name="TextBox 5"/>
           <p:cNvSpPr txBox="1"/>
           <p:nvPr/>
         </p:nvSpPr>
         <p:spPr>
           <a:xfrm>
             <a:off x="731520" y="1508760"/>
-            <a:ext cx="10789920" cy="2834640"/>
+            <a:ext cx="10789920" cy="1133856"/>
           </a:xfrm>
           <a:prstGeom prst="rect">
             <a:avLst/>
@@ -4895,7 +4916,7 @@
                 </a:solidFill>
                 <a:latin typeface="Calibri"/>
               </a:rPr>
-              <a:t>CLB Lịch sử có 12 thành viên</a:t>
+              <a:t>C = {x ∈ ℝ | 2 ≤ x ≤ 7} = [2; 7]</a:t>
             </a:r>
           </a:p>
           <a:p>
@@ -4916,70 +4937,171 @@
                 </a:solidFill>
                 <a:latin typeface="Calibri"/>
               </a:rPr>
-              <a:t>7 bạn dự Chuyên đề 1</a:t>
-            </a:r>
-          </a:p>
-          <a:p>
-            <a:pPr algn="l" marL="365760" indent="-365760">
+              <a:t>D = {x ∈ ℝ | x &lt; 2} = (−∞; 2)</a:t>
+            </a:r>
+          </a:p>
+        </p:txBody>
+      </p:sp>
+      <p:sp>
+        <p:nvSpPr>
+          <p:cNvPr id="7" name="Rounded Rectangle 6"/>
+          <p:cNvSpPr/>
+          <p:nvPr/>
+        </p:nvSpPr>
+        <p:spPr>
+          <a:xfrm>
+            <a:off x="731520" y="2779776"/>
+            <a:ext cx="8686800" cy="685800"/>
+          </a:xfrm>
+          <a:prstGeom prst="roundRect">
+            <a:avLst>
+              <a:gd name="adj" fmla="val 8000"/>
+            </a:avLst>
+          </a:prstGeom>
+          <a:solidFill>
+            <a:srgbClr val="FEF2F2"/>
+          </a:solidFill>
+          <a:ln w="19050">
+            <a:solidFill>
+              <a:srgbClr val="991B1B"/>
+            </a:solidFill>
+          </a:ln>
+          <a:effectLst/>
+        </p:spPr>
+        <p:style>
+          <a:lnRef idx="1">
+            <a:schemeClr val="accent1"/>
+          </a:lnRef>
+          <a:fillRef idx="3">
+            <a:schemeClr val="accent1"/>
+          </a:fillRef>
+          <a:effectRef idx="2">
+            <a:schemeClr val="accent1"/>
+          </a:effectRef>
+          <a:fontRef idx="minor">
+            <a:schemeClr val="lt1"/>
+          </a:fontRef>
+        </p:style>
+        <p:txBody>
+          <a:bodyPr rtlCol="0" anchor="ctr"/>
+          <a:lstStyle/>
+          <a:p>
+            <a:pPr algn="ctr"/>
+          </a:p>
+        </p:txBody>
+      </p:sp>
+      <p:sp>
+        <p:nvSpPr>
+          <p:cNvPr id="8" name="TextBox 7"/>
+          <p:cNvSpPr txBox="1"/>
+          <p:nvPr/>
+        </p:nvSpPr>
+        <p:spPr>
+          <a:xfrm>
+            <a:off x="914400" y="2779776"/>
+            <a:ext cx="8321040" cy="685800"/>
+          </a:xfrm>
+          <a:prstGeom prst="rect">
+            <a:avLst/>
+          </a:prstGeom>
+          <a:noFill/>
+        </p:spPr>
+        <p:txBody>
+          <a:bodyPr wrap="square" anchor="ctr">
+            <a:spAutoFit/>
+          </a:bodyPr>
+          <a:lstStyle/>
+          <a:p>
+            <a:pPr algn="l">
               <a:spcAft>
-                <a:spcPts val="1000"/>
+                <a:spcPts val="400"/>
               </a:spcAft>
-              <a:buClr>
-                <a:srgbClr val="1E40AF"/>
-              </a:buClr>
-              <a:buFont typeface="Arial"/>
-              <a:buChar char="•"/>
             </a:pPr>
             <a:r>
-              <a:rPr sz="2400">
-                <a:solidFill>
-                  <a:srgbClr val="1E293B"/>
-                </a:solidFill>
-                <a:latin typeface="Calibri"/>
-              </a:rPr>
-              <a:t>8 bạn dự Chuyên đề 2</a:t>
-            </a:r>
-          </a:p>
-          <a:p>
-            <a:pPr algn="l" marL="365760" indent="-365760">
-              <a:spcAft>
-                <a:spcPts val="1000"/>
-              </a:spcAft>
-              <a:buClr>
-                <a:srgbClr val="1E40AF"/>
-              </a:buClr>
-              <a:buFont typeface="Arial"/>
-              <a:buChar char="•"/>
-            </a:pPr>
-            <a:r>
-              <a:rPr sz="2400">
-                <a:solidFill>
-                  <a:srgbClr val="1E293B"/>
-                </a:solidFill>
-                <a:latin typeface="Calibri"/>
-              </a:rPr>
-              <a:t>A ∪ B có 10 phần tử</a:t>
-            </a:r>
-          </a:p>
-          <a:p>
-            <a:pPr algn="l" marL="365760" indent="-365760">
-              <a:spcAft>
-                <a:spcPts val="1000"/>
-              </a:spcAft>
-              <a:buClr>
-                <a:srgbClr val="1E40AF"/>
-              </a:buClr>
-              <a:buFont typeface="Arial"/>
-              <a:buChar char="•"/>
-            </a:pPr>
-            <a:r>
-              <a:rPr sz="2400">
-                <a:solidFill>
-                  <a:srgbClr val="1E293B"/>
-                </a:solidFill>
-                <a:latin typeface="Calibri"/>
-              </a:rPr>
-              <a:t>Bao nhiêu bạn vắng cả hai?</a:t>
+              <a:rPr sz="2400" b="1">
+                <a:solidFill>
+                  <a:srgbClr val="991B1B"/>
+                </a:solidFill>
+                <a:latin typeface="Calibri"/>
+              </a:rPr>
+              <a:t>Phần bị gạch là phần bỏ đi</a:t>
+            </a:r>
+          </a:p>
+        </p:txBody>
+      </p:sp>
+      <p:pic>
+        <p:nvPicPr>
+          <p:cNvPr id="9" name="Picture 8" descr="rId14.png"/>
+          <p:cNvPicPr>
+            <a:picLocks noChangeAspect="1"/>
+          </p:cNvPicPr>
+          <p:nvPr/>
+        </p:nvPicPr>
+        <p:blipFill>
+          <a:blip r:embed="rId2"/>
+          <a:stretch>
+            <a:fillRect/>
+          </a:stretch>
+        </p:blipFill>
+        <p:spPr>
+          <a:xfrm>
+            <a:off x="731520" y="3647875"/>
+            <a:ext cx="10698480" cy="2524906"/>
+          </a:xfrm>
+          <a:prstGeom prst="rect">
+            <a:avLst/>
+          </a:prstGeom>
+        </p:spPr>
+      </p:pic>
+      <p:sp>
+        <p:nvSpPr>
+          <p:cNvPr id="10" name="Rounded Rectangle 9"/>
+          <p:cNvSpPr/>
+          <p:nvPr/>
+        </p:nvSpPr>
+        <p:spPr>
+          <a:xfrm>
+            <a:off x="10463479" y="457200"/>
+            <a:ext cx="1179576" cy="457200"/>
+          </a:xfrm>
+          <a:prstGeom prst="roundRect">
+            <a:avLst/>
+          </a:prstGeom>
+          <a:solidFill>
+            <a:srgbClr val="166534"/>
+          </a:solidFill>
+          <a:ln>
+            <a:noFill/>
+          </a:ln>
+          <a:effectLst/>
+        </p:spPr>
+        <p:style>
+          <a:lnRef idx="1">
+            <a:schemeClr val="accent1"/>
+          </a:lnRef>
+          <a:fillRef idx="3">
+            <a:schemeClr val="accent1"/>
+          </a:fillRef>
+          <a:effectRef idx="2">
+            <a:schemeClr val="accent1"/>
+          </a:effectRef>
+          <a:fontRef idx="minor">
+            <a:schemeClr val="lt1"/>
+          </a:fontRef>
+        </p:style>
+        <p:txBody>
+          <a:bodyPr rtlCol="0" anchor="ctr" tIns="0" bIns="0"/>
+          <a:lstStyle/>
+          <a:p>
+            <a:pPr algn="ctr"/>
+            <a:r>
+              <a:rPr sz="1400" b="1">
+                <a:solidFill>
+                  <a:srgbClr val="FFFFFF"/>
+                </a:solidFill>
+                <a:latin typeface="Arial"/>
+              </a:rPr>
+              <a:t>LỜI GIẢI</a:t>
             </a:r>
           </a:p>
         </p:txBody>
@@ -5083,7 +5205,7 @@
                 </a:solidFill>
                 <a:latin typeface="Arial"/>
               </a:rPr>
-              <a:t>HIỆU VÀ PHẦN BÙ</a:t>
+              <a:t>4. GIAO CỦA HAI TẬP HỢP</a:t>
             </a:r>
           </a:p>
         </p:txBody>
@@ -5162,7 +5284,7 @@
                 </a:solidFill>
                 <a:latin typeface="Calibri"/>
               </a:rPr>
-              <a:t>Toán 10 · Bài 2. Tập hợp và các phép toán trên tập hợp          19</a:t>
+              <a:t>Toán 10 · Bài 2. Tập hợp và các phép toán trên tập hợp          15</a:t>
             </a:r>
           </a:p>
         </p:txBody>
@@ -5206,7 +5328,7 @@
                 </a:solidFill>
                 <a:latin typeface="Calibri"/>
               </a:rPr>
-              <a:t>S \ T: thuộc S nhưng không thuộc T</a:t>
+              <a:t>Phần tử thuộc cả S và T</a:t>
             </a:r>
           </a:p>
           <a:p>
@@ -5227,25 +5349,7 @@
                 </a:solidFill>
                 <a:latin typeface="Calibri"/>
               </a:rPr>
-              <a:t>C</a:t>
-            </a:r>
-            <a:r>
-              <a:rPr sz="2400" baseline="-25000">
-                <a:solidFill>
-                  <a:srgbClr val="1E293B"/>
-                </a:solidFill>
-                <a:latin typeface="Calibri"/>
-              </a:rPr>
-              <a:t>ℝ</a:t>
-            </a:r>
-            <a:r>
-              <a:rPr sz="2400">
-                <a:solidFill>
-                  <a:srgbClr val="1E293B"/>
-                </a:solidFill>
-                <a:latin typeface="Calibri"/>
-              </a:rPr>
-              <a:t>(−∞; −2) = [−2; +∞)</a:t>
+              <a:t>{4; 7; 27} ∩ {2; 4; 9; 27; 36} = {4; 27}</a:t>
             </a:r>
           </a:p>
           <a:p>
@@ -5266,25 +5370,7 @@
                 </a:solidFill>
                 <a:latin typeface="Calibri"/>
               </a:rPr>
-              <a:t>C</a:t>
-            </a:r>
-            <a:r>
-              <a:rPr sz="2400" baseline="-25000">
-                <a:solidFill>
-                  <a:srgbClr val="1E293B"/>
-                </a:solidFill>
-                <a:latin typeface="Calibri"/>
-              </a:rPr>
-              <a:t>ℝ</a:t>
-            </a:r>
-            <a:r>
-              <a:rPr sz="2400">
-                <a:solidFill>
-                  <a:srgbClr val="1E293B"/>
-                </a:solidFill>
-                <a:latin typeface="Calibri"/>
-              </a:rPr>
-              <a:t>[−5; +∞) = (−∞; −5)</a:t>
+              <a:t>[1; +∞) ∩ (−∞; 3] = [1; 3]</a:t>
             </a:r>
           </a:p>
         </p:txBody>
@@ -5298,7 +5384,7 @@
         <p:spPr>
           <a:xfrm>
             <a:off x="731520" y="3346704"/>
-            <a:ext cx="6400800" cy="1143000"/>
+            <a:ext cx="6400800" cy="685800"/>
           </a:xfrm>
           <a:prstGeom prst="roundRect">
             <a:avLst>
@@ -5346,7 +5432,7 @@
         <p:spPr>
           <a:xfrm>
             <a:off x="914400" y="3346704"/>
-            <a:ext cx="6035040" cy="1143000"/>
+            <a:ext cx="6035040" cy="685800"/>
           </a:xfrm>
           <a:prstGeom prst="rect">
             <a:avLst/>
@@ -5371,48 +5457,14 @@
                 </a:solidFill>
                 <a:latin typeface="Calibri"/>
               </a:rPr>
-              <a:t>S \ T = {x | x ∈ S và x ∉ T}</a:t>
-            </a:r>
-          </a:p>
-          <a:p>
-            <a:pPr algn="l">
-              <a:spcAft>
-                <a:spcPts val="400"/>
-              </a:spcAft>
-            </a:pPr>
-            <a:r>
-              <a:rPr sz="2400" b="1">
-                <a:solidFill>
-                  <a:srgbClr val="991B1B"/>
-                </a:solidFill>
-                <a:latin typeface="Calibri"/>
-              </a:rPr>
-              <a:t>T ⊂ S:  C</a:t>
-            </a:r>
-            <a:r>
-              <a:rPr sz="2400" b="1" baseline="-25000">
-                <a:solidFill>
-                  <a:srgbClr val="991B1B"/>
-                </a:solidFill>
-                <a:latin typeface="Calibri"/>
-              </a:rPr>
-              <a:t>S</a:t>
-            </a:r>
-            <a:r>
-              <a:rPr sz="2400" b="1">
-                <a:solidFill>
-                  <a:srgbClr val="991B1B"/>
-                </a:solidFill>
-                <a:latin typeface="Calibri"/>
-              </a:rPr>
-              <a:t>T = S \ T</a:t>
+              <a:t>S ∩ T = {x | x ∈ S và x ∈ T}</a:t>
             </a:r>
           </a:p>
         </p:txBody>
       </p:sp>
       <p:pic>
         <p:nvPicPr>
-          <p:cNvPr id="9" name="Picture 8" descr="rId19.png"/>
+          <p:cNvPr id="9" name="Picture 8" descr="rId15.png"/>
           <p:cNvPicPr>
             <a:picLocks noChangeAspect="1"/>
           </p:cNvPicPr>
@@ -5426,8 +5478,8 @@
         </p:blipFill>
         <p:spPr>
           <a:xfrm>
-            <a:off x="7840893" y="1463040"/>
-            <a:ext cx="3520614" cy="4709160"/>
+            <a:off x="7406640" y="2356536"/>
+            <a:ext cx="4389120" cy="2922168"/>
           </a:xfrm>
           <a:prstGeom prst="rect">
             <a:avLst/>
@@ -5533,7 +5585,7 @@
                 </a:solidFill>
                 <a:latin typeface="Arial"/>
               </a:rPr>
-              <a:t>VẬN DỤNG: ĐẾM SỐ PHẦN TỬ</a:t>
+              <a:t>HỢP CỦA HAI TẬP HỢP</a:t>
             </a:r>
           </a:p>
         </p:txBody>
@@ -5612,7 +5664,7 @@
                 </a:solidFill>
                 <a:latin typeface="Calibri"/>
               </a:rPr>
-              <a:t>Toán 10 · Bài 2. Tập hợp và các phép toán trên tập hợp          20</a:t>
+              <a:t>Toán 10 · Bài 2. Tập hợp và các phép toán trên tập hợp          16</a:t>
             </a:r>
           </a:p>
         </p:txBody>
@@ -5626,7 +5678,7 @@
         <p:spPr>
           <a:xfrm>
             <a:off x="731520" y="1508760"/>
-            <a:ext cx="10789920" cy="2834640"/>
+            <a:ext cx="6400800" cy="2267712"/>
           </a:xfrm>
           <a:prstGeom prst="rect">
             <a:avLst/>
@@ -5656,7 +5708,7 @@
                 </a:solidFill>
                 <a:latin typeface="Calibri"/>
               </a:rPr>
-              <a:t>Lớp 10A: 24 bạn thi đấu</a:t>
+              <a:t>Phần tử thuộc S hoặc thuộc T</a:t>
             </a:r>
           </a:p>
           <a:p>
@@ -5677,7 +5729,7 @@
                 </a:solidFill>
                 <a:latin typeface="Calibri"/>
               </a:rPr>
-              <a:t>Bóng đá 16 bạn, cầu lông 11 bạn</a:t>
+              <a:t>{2; 3; 4; 7} ∪ {−1; 2; 3; 4; 6}</a:t>
             </a:r>
           </a:p>
           <a:p>
@@ -5698,7 +5750,7 @@
                 </a:solidFill>
                 <a:latin typeface="Calibri"/>
               </a:rPr>
-              <a:t>Mỗi bạn thi ít nhất một môn</a:t>
+              <a:t>= {−1; 2; 3; 4; 6; 7}</a:t>
             </a:r>
           </a:p>
           <a:p>
@@ -5719,27 +5771,122 @@
                 </a:solidFill>
                 <a:latin typeface="Calibri"/>
               </a:rPr>
-              <a:t>Bao nhiêu bạn thi cả hai môn?</a:t>
-            </a:r>
-          </a:p>
+              <a:t>(−1; 2] ∪ [0; 3] = (−1; 3]</a:t>
+            </a:r>
+          </a:p>
+        </p:txBody>
+      </p:sp>
+      <p:sp>
+        <p:nvSpPr>
+          <p:cNvPr id="7" name="Rounded Rectangle 6"/>
+          <p:cNvSpPr/>
+          <p:nvPr/>
+        </p:nvSpPr>
+        <p:spPr>
+          <a:xfrm>
+            <a:off x="731520" y="3913632"/>
+            <a:ext cx="6400800" cy="685800"/>
+          </a:xfrm>
+          <a:prstGeom prst="roundRect">
+            <a:avLst>
+              <a:gd name="adj" fmla="val 8000"/>
+            </a:avLst>
+          </a:prstGeom>
+          <a:solidFill>
+            <a:srgbClr val="FEF2F2"/>
+          </a:solidFill>
+          <a:ln w="19050">
+            <a:solidFill>
+              <a:srgbClr val="991B1B"/>
+            </a:solidFill>
+          </a:ln>
+          <a:effectLst/>
+        </p:spPr>
+        <p:style>
+          <a:lnRef idx="1">
+            <a:schemeClr val="accent1"/>
+          </a:lnRef>
+          <a:fillRef idx="3">
+            <a:schemeClr val="accent1"/>
+          </a:fillRef>
+          <a:effectRef idx="2">
+            <a:schemeClr val="accent1"/>
+          </a:effectRef>
+          <a:fontRef idx="minor">
+            <a:schemeClr val="lt1"/>
+          </a:fontRef>
+        </p:style>
+        <p:txBody>
+          <a:bodyPr rtlCol="0" anchor="ctr"/>
+          <a:lstStyle/>
+          <a:p>
+            <a:pPr algn="ctr"/>
+          </a:p>
+        </p:txBody>
+      </p:sp>
+      <p:sp>
+        <p:nvSpPr>
+          <p:cNvPr id="8" name="TextBox 7"/>
+          <p:cNvSpPr txBox="1"/>
+          <p:nvPr/>
+        </p:nvSpPr>
+        <p:spPr>
+          <a:xfrm>
+            <a:off x="914400" y="3913632"/>
+            <a:ext cx="6035040" cy="685800"/>
+          </a:xfrm>
+          <a:prstGeom prst="rect">
+            <a:avLst/>
+          </a:prstGeom>
+          <a:noFill/>
+        </p:spPr>
+        <p:txBody>
+          <a:bodyPr wrap="square" anchor="ctr">
+            <a:spAutoFit/>
+          </a:bodyPr>
+          <a:lstStyle/>
           <a:p>
             <a:pPr algn="l">
               <a:spcAft>
-                <a:spcPts val="1000"/>
+                <a:spcPts val="400"/>
               </a:spcAft>
             </a:pPr>
             <a:r>
               <a:rPr sz="2400" b="1">
                 <a:solidFill>
-                  <a:srgbClr val="1E40AF"/>
-                </a:solidFill>
-                <a:latin typeface="Calibri"/>
-              </a:rPr>
-              <a:t>Gợi mở: Vẽ biểu đồ Ven</a:t>
-            </a:r>
-          </a:p>
-        </p:txBody>
-      </p:sp>
+                  <a:srgbClr val="991B1B"/>
+                </a:solidFill>
+                <a:latin typeface="Calibri"/>
+              </a:rPr>
+              <a:t>S ∪ T = {x | x ∈ S hoặc x ∈ T}</a:t>
+            </a:r>
+          </a:p>
+        </p:txBody>
+      </p:sp>
+      <p:pic>
+        <p:nvPicPr>
+          <p:cNvPr id="9" name="Picture 8" descr="rId17.png"/>
+          <p:cNvPicPr>
+            <a:picLocks noChangeAspect="1"/>
+          </p:cNvPicPr>
+          <p:nvPr/>
+        </p:nvPicPr>
+        <p:blipFill>
+          <a:blip r:embed="rId2"/>
+          <a:stretch>
+            <a:fillRect/>
+          </a:stretch>
+        </p:blipFill>
+        <p:spPr>
+          <a:xfrm>
+            <a:off x="7406640" y="2344641"/>
+            <a:ext cx="4389120" cy="2945958"/>
+          </a:xfrm>
+          <a:prstGeom prst="rect">
+            <a:avLst/>
+          </a:prstGeom>
+        </p:spPr>
+      </p:pic>
     </p:spTree>
   </p:cSld>
   <p:clrMapOvr>
@@ -5819,7 +5966,7 @@
         <p:spPr>
           <a:xfrm>
             <a:off x="731520" y="274320"/>
-            <a:ext cx="10972800" cy="868680"/>
+            <a:ext cx="9848088" cy="868680"/>
           </a:xfrm>
           <a:prstGeom prst="rect">
             <a:avLst/>
@@ -5839,7 +5986,7 @@
                 </a:solidFill>
                 <a:latin typeface="Arial"/>
               </a:rPr>
-              <a:t>TRẠM KIỂM CHỨNG AI</a:t>
+              <a:t>TRỞ LẠI KHỞI ĐỘNG</a:t>
             </a:r>
           </a:p>
         </p:txBody>
@@ -5918,21 +6065,45 @@
                 </a:solidFill>
                 <a:latin typeface="Calibri"/>
               </a:rPr>
-              <a:t>Toán 10 · Bài 2. Tập hợp và các phép toán trên tập hợp          22</a:t>
-            </a:r>
-          </a:p>
-        </p:txBody>
-      </p:sp>
-      <p:sp>
-        <p:nvSpPr>
-          <p:cNvPr id="6" name="TextBox 5"/>
+              <a:t>Toán 10 · Bài 2. Tập hợp và các phép toán trên tập hợp          17</a:t>
+            </a:r>
+          </a:p>
+        </p:txBody>
+      </p:sp>
+      <p:pic>
+        <p:nvPicPr>
+          <p:cNvPr id="9" name="Picture 8" descr="rId9.png"/>
+          <p:cNvPicPr>
+            <a:picLocks noChangeAspect="1"/>
+          </p:cNvPicPr>
+          <p:nvPr/>
+        </p:nvPicPr>
+        <p:blipFill>
+          <a:blip r:embed="rId2"/>
+          <a:stretch>
+            <a:fillRect/>
+          </a:stretch>
+        </p:blipFill>
+        <p:spPr>
+          <a:xfrm>
+            <a:off x="4023291" y="4169664"/>
+            <a:ext cx="4114937" cy="2048256"/>
+          </a:xfrm>
+          <a:prstGeom prst="rect">
+            <a:avLst/>
+          </a:prstGeom>
+        </p:spPr>
+      </p:pic>
+      <p:sp>
+        <p:nvSpPr>
+          <p:cNvPr id="10" name="TextBox 9"/>
           <p:cNvSpPr txBox="1"/>
           <p:nvPr/>
         </p:nvSpPr>
         <p:spPr>
           <a:xfrm>
             <a:off x="731520" y="1508760"/>
-            <a:ext cx="10789920" cy="1700784"/>
+            <a:ext cx="10789920" cy="2834640"/>
           </a:xfrm>
           <a:prstGeom prst="rect">
             <a:avLst/>
@@ -5962,7 +6133,7 @@
                 </a:solidFill>
                 <a:latin typeface="Calibri"/>
               </a:rPr>
-              <a:t>Hỏi AI: (−2; 1] ∩ (1; +∞) = ?</a:t>
+              <a:t>CLB Lịch sử có 12 thành viên</a:t>
             </a:r>
           </a:p>
           <a:p>
@@ -5983,23 +6154,123 @@
                 </a:solidFill>
                 <a:latin typeface="Calibri"/>
               </a:rPr>
-              <a:t>Đối chiếu câu trả lời của AI</a:t>
-            </a:r>
-          </a:p>
-          <a:p>
-            <a:pPr algn="l">
+              <a:t>7 bạn dự Chuyên đề 1</a:t>
+            </a:r>
+          </a:p>
+          <a:p>
+            <a:pPr algn="l" marL="365760" indent="-365760">
               <a:spcAft>
                 <a:spcPts val="1000"/>
               </a:spcAft>
+              <a:buClr>
+                <a:srgbClr val="1E40AF"/>
+              </a:buClr>
+              <a:buFont typeface="Arial"/>
+              <a:buChar char="•"/>
             </a:pPr>
             <a:r>
-              <a:rPr sz="2400" b="1">
-                <a:solidFill>
-                  <a:srgbClr val="1E40AF"/>
-                </a:solidFill>
-                <a:latin typeface="Calibri"/>
-              </a:rPr>
-              <a:t>Gợi mở: Tìm bước sai, giải thích, sửa lại</a:t>
+              <a:rPr sz="2400">
+                <a:solidFill>
+                  <a:srgbClr val="1E293B"/>
+                </a:solidFill>
+                <a:latin typeface="Calibri"/>
+              </a:rPr>
+              <a:t>8 bạn dự Chuyên đề 2</a:t>
+            </a:r>
+          </a:p>
+          <a:p>
+            <a:pPr algn="l" marL="365760" indent="-365760">
+              <a:spcAft>
+                <a:spcPts val="1000"/>
+              </a:spcAft>
+              <a:buClr>
+                <a:srgbClr val="1E40AF"/>
+              </a:buClr>
+              <a:buFont typeface="Arial"/>
+              <a:buChar char="•"/>
+            </a:pPr>
+            <a:r>
+              <a:rPr sz="2400">
+                <a:solidFill>
+                  <a:srgbClr val="1E293B"/>
+                </a:solidFill>
+                <a:latin typeface="Calibri"/>
+              </a:rPr>
+              <a:t>A ∪ B có 10 phần tử</a:t>
+            </a:r>
+          </a:p>
+          <a:p>
+            <a:pPr algn="l" marL="365760" indent="-365760">
+              <a:spcAft>
+                <a:spcPts val="1000"/>
+              </a:spcAft>
+              <a:buClr>
+                <a:srgbClr val="1E40AF"/>
+              </a:buClr>
+              <a:buFont typeface="Arial"/>
+              <a:buChar char="•"/>
+            </a:pPr>
+            <a:r>
+              <a:rPr sz="2400">
+                <a:solidFill>
+                  <a:srgbClr val="1E293B"/>
+                </a:solidFill>
+                <a:latin typeface="Calibri"/>
+              </a:rPr>
+              <a:t>Bao nhiêu bạn vắng cả hai?</a:t>
+            </a:r>
+          </a:p>
+        </p:txBody>
+      </p:sp>
+      <p:sp>
+        <p:nvSpPr>
+          <p:cNvPr id="11" name="Rounded Rectangle 10"/>
+          <p:cNvSpPr/>
+          <p:nvPr/>
+        </p:nvSpPr>
+        <p:spPr>
+          <a:xfrm>
+            <a:off x="10701223" y="457200"/>
+            <a:ext cx="941832" cy="457200"/>
+          </a:xfrm>
+          <a:prstGeom prst="roundRect">
+            <a:avLst/>
+          </a:prstGeom>
+          <a:solidFill>
+            <a:srgbClr val="1E40AF"/>
+          </a:solidFill>
+          <a:ln>
+            <a:noFill/>
+          </a:ln>
+          <a:effectLst/>
+        </p:spPr>
+        <p:style>
+          <a:lnRef idx="1">
+            <a:schemeClr val="accent1"/>
+          </a:lnRef>
+          <a:fillRef idx="3">
+            <a:schemeClr val="accent1"/>
+          </a:fillRef>
+          <a:effectRef idx="2">
+            <a:schemeClr val="accent1"/>
+          </a:effectRef>
+          <a:fontRef idx="minor">
+            <a:schemeClr val="lt1"/>
+          </a:fontRef>
+        </p:style>
+        <p:txBody>
+          <a:bodyPr rtlCol="0" anchor="ctr" tIns="0" bIns="0"/>
+          <a:lstStyle/>
+          <a:p>
+            <a:pPr algn="ctr"/>
+            <a:r>
+              <a:rPr sz="1400" b="1">
+                <a:solidFill>
+                  <a:srgbClr val="FFFFFF"/>
+                </a:solidFill>
+                <a:latin typeface="Arial"/>
+              </a:rPr>
+              <a:t>ĐỀ BÀI</a:t>
             </a:r>
           </a:p>
         </p:txBody>
@@ -6083,7 +6354,7 @@
         <p:spPr>
           <a:xfrm>
             <a:off x="731520" y="274320"/>
-            <a:ext cx="10972800" cy="868680"/>
+            <a:ext cx="9610344" cy="868680"/>
           </a:xfrm>
           <a:prstGeom prst="rect">
             <a:avLst/>
@@ -6103,7 +6374,7 @@
                 </a:solidFill>
                 <a:latin typeface="Arial"/>
               </a:rPr>
-              <a:t>NHIỆM VỤ VỀ NHÀ: LỚP MÌNH QUA BIỂU ĐỒ VEN</a:t>
+              <a:t>TRỞ LẠI KHỞI ĐỘNG</a:t>
             </a:r>
           </a:p>
         </p:txBody>
@@ -6182,7 +6453,7 @@
                 </a:solidFill>
                 <a:latin typeface="Calibri"/>
               </a:rPr>
-              <a:t>Toán 10 · Bài 2. Tập hợp và các phép toán trên tập hợp          24</a:t>
+              <a:t>Toán 10 · Bài 2. Tập hợp và các phép toán trên tập hợp          18</a:t>
             </a:r>
           </a:p>
         </p:txBody>
@@ -6196,7 +6467,7 @@
         <p:spPr>
           <a:xfrm>
             <a:off x="731520" y="1508760"/>
-            <a:ext cx="10789920" cy="2834640"/>
+            <a:ext cx="10789920" cy="1700784"/>
           </a:xfrm>
           <a:prstGeom prst="rect">
             <a:avLst/>
@@ -6226,7 +6497,7 @@
                 </a:solidFill>
                 <a:latin typeface="Calibri"/>
               </a:rPr>
-              <a:t>Tạo Google Forms 2 câu Có/Không</a:t>
+              <a:t>A: 7 bạn dự Chuyên đề 1</a:t>
             </a:r>
           </a:p>
           <a:p>
@@ -6247,7 +6518,7 @@
                 </a:solidFill>
                 <a:latin typeface="Calibri"/>
               </a:rPr>
-              <a:t>Không thu họ tên, số điện thoại</a:t>
+              <a:t>B: 8 bạn dự Chuyên đề 2</a:t>
             </a:r>
           </a:p>
           <a:p>
@@ -6268,49 +6539,171 @@
                 </a:solidFill>
                 <a:latin typeface="Calibri"/>
               </a:rPr>
-              <a:t>Lọc, đếm bằng Google Sheets</a:t>
-            </a:r>
-          </a:p>
-          <a:p>
-            <a:pPr algn="l" marL="365760" indent="-365760">
+              <a:t>A ∪ B có 10 phần tử</a:t>
+            </a:r>
+          </a:p>
+        </p:txBody>
+      </p:sp>
+      <p:sp>
+        <p:nvSpPr>
+          <p:cNvPr id="7" name="Rounded Rectangle 6"/>
+          <p:cNvSpPr/>
+          <p:nvPr/>
+        </p:nvSpPr>
+        <p:spPr>
+          <a:xfrm>
+            <a:off x="731520" y="3346704"/>
+            <a:ext cx="8686800" cy="685800"/>
+          </a:xfrm>
+          <a:prstGeom prst="roundRect">
+            <a:avLst>
+              <a:gd name="adj" fmla="val 8000"/>
+            </a:avLst>
+          </a:prstGeom>
+          <a:solidFill>
+            <a:srgbClr val="FEF2F2"/>
+          </a:solidFill>
+          <a:ln w="19050">
+            <a:solidFill>
+              <a:srgbClr val="991B1B"/>
+            </a:solidFill>
+          </a:ln>
+          <a:effectLst/>
+        </p:spPr>
+        <p:style>
+          <a:lnRef idx="1">
+            <a:schemeClr val="accent1"/>
+          </a:lnRef>
+          <a:fillRef idx="3">
+            <a:schemeClr val="accent1"/>
+          </a:fillRef>
+          <a:effectRef idx="2">
+            <a:schemeClr val="accent1"/>
+          </a:effectRef>
+          <a:fontRef idx="minor">
+            <a:schemeClr val="lt1"/>
+          </a:fontRef>
+        </p:style>
+        <p:txBody>
+          <a:bodyPr rtlCol="0" anchor="ctr"/>
+          <a:lstStyle/>
+          <a:p>
+            <a:pPr algn="ctr"/>
+          </a:p>
+        </p:txBody>
+      </p:sp>
+      <p:sp>
+        <p:nvSpPr>
+          <p:cNvPr id="8" name="TextBox 7"/>
+          <p:cNvSpPr txBox="1"/>
+          <p:nvPr/>
+        </p:nvSpPr>
+        <p:spPr>
+          <a:xfrm>
+            <a:off x="914400" y="3346704"/>
+            <a:ext cx="8321040" cy="685800"/>
+          </a:xfrm>
+          <a:prstGeom prst="rect">
+            <a:avLst/>
+          </a:prstGeom>
+          <a:noFill/>
+        </p:spPr>
+        <p:txBody>
+          <a:bodyPr wrap="square" anchor="ctr">
+            <a:spAutoFit/>
+          </a:bodyPr>
+          <a:lstStyle/>
+          <a:p>
+            <a:pPr algn="l">
               <a:spcAft>
-                <a:spcPts val="1000"/>
+                <a:spcPts val="400"/>
               </a:spcAft>
-              <a:buClr>
-                <a:srgbClr val="1E40AF"/>
-              </a:buClr>
-              <a:buFont typeface="Arial"/>
-              <a:buChar char="•"/>
             </a:pPr>
             <a:r>
-              <a:rPr sz="2400">
-                <a:solidFill>
-                  <a:srgbClr val="1E293B"/>
-                </a:solidFill>
-                <a:latin typeface="Calibri"/>
-              </a:rPr>
-              <a:t>Vẽ biểu đồ Ven, thử công thức</a:t>
-            </a:r>
-          </a:p>
-          <a:p>
-            <a:pPr algn="l" marL="365760" indent="-365760">
-              <a:spcAft>
-                <a:spcPts val="1000"/>
-              </a:spcAft>
-              <a:buClr>
-                <a:srgbClr val="1E40AF"/>
-              </a:buClr>
-              <a:buFont typeface="Arial"/>
-              <a:buChar char="•"/>
-            </a:pPr>
-            <a:r>
-              <a:rPr sz="2400">
-                <a:solidFill>
-                  <a:srgbClr val="1E293B"/>
-                </a:solidFill>
-                <a:latin typeface="Calibri"/>
-              </a:rPr>
-              <a:t>Nộp 3–5 slide trên Padlet</a:t>
+              <a:rPr sz="2400" b="1">
+                <a:solidFill>
+                  <a:srgbClr val="991B1B"/>
+                </a:solidFill>
+                <a:latin typeface="Calibri"/>
+              </a:rPr>
+              <a:t>Vắng cả hai: 12 − 10 = 2 bạn</a:t>
+            </a:r>
+          </a:p>
+        </p:txBody>
+      </p:sp>
+      <p:pic>
+        <p:nvPicPr>
+          <p:cNvPr id="9" name="Picture 8" descr="rId9.png"/>
+          <p:cNvPicPr>
+            <a:picLocks noChangeAspect="1"/>
+          </p:cNvPicPr>
+          <p:nvPr/>
+        </p:nvPicPr>
+        <p:blipFill>
+          <a:blip r:embed="rId2"/>
+          <a:stretch>
+            <a:fillRect/>
+          </a:stretch>
+        </p:blipFill>
+        <p:spPr>
+          <a:xfrm>
+            <a:off x="4023291" y="4169664"/>
+            <a:ext cx="4114937" cy="2048256"/>
+          </a:xfrm>
+          <a:prstGeom prst="rect">
+            <a:avLst/>
+          </a:prstGeom>
+        </p:spPr>
+      </p:pic>
+      <p:sp>
+        <p:nvSpPr>
+          <p:cNvPr id="10" name="Rounded Rectangle 9"/>
+          <p:cNvSpPr/>
+          <p:nvPr/>
+        </p:nvSpPr>
+        <p:spPr>
+          <a:xfrm>
+            <a:off x="10463479" y="457200"/>
+            <a:ext cx="1179576" cy="457200"/>
+          </a:xfrm>
+          <a:prstGeom prst="roundRect">
+            <a:avLst/>
+          </a:prstGeom>
+          <a:solidFill>
+            <a:srgbClr val="166534"/>
+          </a:solidFill>
+          <a:ln>
+            <a:noFill/>
+          </a:ln>
+          <a:effectLst/>
+        </p:spPr>
+        <p:style>
+          <a:lnRef idx="1">
+            <a:schemeClr val="accent1"/>
+          </a:lnRef>
+          <a:fillRef idx="3">
+            <a:schemeClr val="accent1"/>
+          </a:fillRef>
+          <a:effectRef idx="2">
+            <a:schemeClr val="accent1"/>
+          </a:effectRef>
+          <a:fontRef idx="minor">
+            <a:schemeClr val="lt1"/>
+          </a:fontRef>
+        </p:style>
+        <p:txBody>
+          <a:bodyPr rtlCol="0" anchor="ctr" tIns="0" bIns="0"/>
+          <a:lstStyle/>
+          <a:p>
+            <a:pPr algn="ctr"/>
+            <a:r>
+              <a:rPr sz="1400" b="1">
+                <a:solidFill>
+                  <a:srgbClr val="FFFFFF"/>
+                </a:solidFill>
+                <a:latin typeface="Arial"/>
+              </a:rPr>
+              <a:t>LỜI GIẢI</a:t>
             </a:r>
           </a:p>
         </p:txBody>
@@ -6414,7 +6807,7 @@
                 </a:solidFill>
                 <a:latin typeface="Arial"/>
               </a:rPr>
-              <a:t>SƠ ĐỒ TƯ DUY BÀI HỌC</a:t>
+              <a:t>HIỆU VÀ PHẦN BÙ</a:t>
             </a:r>
           </a:p>
         </p:txBody>
@@ -6493,14 +6886,257 @@
                 </a:solidFill>
                 <a:latin typeface="Calibri"/>
               </a:rPr>
-              <a:t>Toán 10 · Bài 2. Tập hợp và các phép toán trên tập hợp          25</a:t>
+              <a:t>Toán 10 · Bài 2. Tập hợp và các phép toán trên tập hợp          19</a:t>
+            </a:r>
+          </a:p>
+        </p:txBody>
+      </p:sp>
+      <p:sp>
+        <p:nvSpPr>
+          <p:cNvPr id="6" name="TextBox 5"/>
+          <p:cNvSpPr txBox="1"/>
+          <p:nvPr/>
+        </p:nvSpPr>
+        <p:spPr>
+          <a:xfrm>
+            <a:off x="731520" y="1508760"/>
+            <a:ext cx="6400800" cy="1700784"/>
+          </a:xfrm>
+          <a:prstGeom prst="rect">
+            <a:avLst/>
+          </a:prstGeom>
+          <a:noFill/>
+        </p:spPr>
+        <p:txBody>
+          <a:bodyPr wrap="square" anchor="t">
+            <a:spAutoFit/>
+          </a:bodyPr>
+          <a:lstStyle/>
+          <a:p>
+            <a:pPr algn="l" marL="365760" indent="-365760">
+              <a:spcAft>
+                <a:spcPts val="1000"/>
+              </a:spcAft>
+              <a:buClr>
+                <a:srgbClr val="1E40AF"/>
+              </a:buClr>
+              <a:buFont typeface="Arial"/>
+              <a:buChar char="•"/>
+            </a:pPr>
+            <a:r>
+              <a:rPr sz="2400">
+                <a:solidFill>
+                  <a:srgbClr val="1E293B"/>
+                </a:solidFill>
+                <a:latin typeface="Calibri"/>
+              </a:rPr>
+              <a:t>S \ T: thuộc S nhưng không thuộc T</a:t>
+            </a:r>
+          </a:p>
+          <a:p>
+            <a:pPr algn="l" marL="365760" indent="-365760">
+              <a:spcAft>
+                <a:spcPts val="1000"/>
+              </a:spcAft>
+              <a:buClr>
+                <a:srgbClr val="1E40AF"/>
+              </a:buClr>
+              <a:buFont typeface="Arial"/>
+              <a:buChar char="•"/>
+            </a:pPr>
+            <a:r>
+              <a:rPr sz="2400">
+                <a:solidFill>
+                  <a:srgbClr val="1E293B"/>
+                </a:solidFill>
+                <a:latin typeface="Calibri"/>
+              </a:rPr>
+              <a:t>C</a:t>
+            </a:r>
+            <a:r>
+              <a:rPr sz="2400" baseline="-25000">
+                <a:solidFill>
+                  <a:srgbClr val="1E293B"/>
+                </a:solidFill>
+                <a:latin typeface="Calibri"/>
+              </a:rPr>
+              <a:t>ℝ</a:t>
+            </a:r>
+            <a:r>
+              <a:rPr sz="2400">
+                <a:solidFill>
+                  <a:srgbClr val="1E293B"/>
+                </a:solidFill>
+                <a:latin typeface="Calibri"/>
+              </a:rPr>
+              <a:t>(−∞; −2) = [−2; +∞)</a:t>
+            </a:r>
+          </a:p>
+          <a:p>
+            <a:pPr algn="l" marL="365760" indent="-365760">
+              <a:spcAft>
+                <a:spcPts val="1000"/>
+              </a:spcAft>
+              <a:buClr>
+                <a:srgbClr val="1E40AF"/>
+              </a:buClr>
+              <a:buFont typeface="Arial"/>
+              <a:buChar char="•"/>
+            </a:pPr>
+            <a:r>
+              <a:rPr sz="2400">
+                <a:solidFill>
+                  <a:srgbClr val="1E293B"/>
+                </a:solidFill>
+                <a:latin typeface="Calibri"/>
+              </a:rPr>
+              <a:t>C</a:t>
+            </a:r>
+            <a:r>
+              <a:rPr sz="2400" baseline="-25000">
+                <a:solidFill>
+                  <a:srgbClr val="1E293B"/>
+                </a:solidFill>
+                <a:latin typeface="Calibri"/>
+              </a:rPr>
+              <a:t>ℝ</a:t>
+            </a:r>
+            <a:r>
+              <a:rPr sz="2400">
+                <a:solidFill>
+                  <a:srgbClr val="1E293B"/>
+                </a:solidFill>
+                <a:latin typeface="Calibri"/>
+              </a:rPr>
+              <a:t>[−5; +∞) = (−∞; −5)</a:t>
+            </a:r>
+          </a:p>
+        </p:txBody>
+      </p:sp>
+      <p:sp>
+        <p:nvSpPr>
+          <p:cNvPr id="7" name="Rounded Rectangle 6"/>
+          <p:cNvSpPr/>
+          <p:nvPr/>
+        </p:nvSpPr>
+        <p:spPr>
+          <a:xfrm>
+            <a:off x="731520" y="3346704"/>
+            <a:ext cx="6400800" cy="1143000"/>
+          </a:xfrm>
+          <a:prstGeom prst="roundRect">
+            <a:avLst>
+              <a:gd name="adj" fmla="val 8000"/>
+            </a:avLst>
+          </a:prstGeom>
+          <a:solidFill>
+            <a:srgbClr val="FEF2F2"/>
+          </a:solidFill>
+          <a:ln w="19050">
+            <a:solidFill>
+              <a:srgbClr val="991B1B"/>
+            </a:solidFill>
+          </a:ln>
+          <a:effectLst/>
+        </p:spPr>
+        <p:style>
+          <a:lnRef idx="1">
+            <a:schemeClr val="accent1"/>
+          </a:lnRef>
+          <a:fillRef idx="3">
+            <a:schemeClr val="accent1"/>
+          </a:fillRef>
+          <a:effectRef idx="2">
+            <a:schemeClr val="accent1"/>
+          </a:effectRef>
+          <a:fontRef idx="minor">
+            <a:schemeClr val="lt1"/>
+          </a:fontRef>
+        </p:style>
+        <p:txBody>
+          <a:bodyPr rtlCol="0" anchor="ctr"/>
+          <a:lstStyle/>
+          <a:p>
+            <a:pPr algn="ctr"/>
+          </a:p>
+        </p:txBody>
+      </p:sp>
+      <p:sp>
+        <p:nvSpPr>
+          <p:cNvPr id="8" name="TextBox 7"/>
+          <p:cNvSpPr txBox="1"/>
+          <p:nvPr/>
+        </p:nvSpPr>
+        <p:spPr>
+          <a:xfrm>
+            <a:off x="914400" y="3346704"/>
+            <a:ext cx="6035040" cy="1143000"/>
+          </a:xfrm>
+          <a:prstGeom prst="rect">
+            <a:avLst/>
+          </a:prstGeom>
+          <a:noFill/>
+        </p:spPr>
+        <p:txBody>
+          <a:bodyPr wrap="square" anchor="ctr">
+            <a:spAutoFit/>
+          </a:bodyPr>
+          <a:lstStyle/>
+          <a:p>
+            <a:pPr algn="l">
+              <a:spcAft>
+                <a:spcPts val="400"/>
+              </a:spcAft>
+            </a:pPr>
+            <a:r>
+              <a:rPr sz="2400" b="1">
+                <a:solidFill>
+                  <a:srgbClr val="991B1B"/>
+                </a:solidFill>
+                <a:latin typeface="Calibri"/>
+              </a:rPr>
+              <a:t>S \ T = {x | x ∈ S và x ∉ T}</a:t>
+            </a:r>
+          </a:p>
+          <a:p>
+            <a:pPr algn="l">
+              <a:spcAft>
+                <a:spcPts val="400"/>
+              </a:spcAft>
+            </a:pPr>
+            <a:r>
+              <a:rPr sz="2400" b="1">
+                <a:solidFill>
+                  <a:srgbClr val="991B1B"/>
+                </a:solidFill>
+                <a:latin typeface="Calibri"/>
+              </a:rPr>
+              <a:t>T ⊂ S:  C</a:t>
+            </a:r>
+            <a:r>
+              <a:rPr sz="2400" b="1" baseline="-25000">
+                <a:solidFill>
+                  <a:srgbClr val="991B1B"/>
+                </a:solidFill>
+                <a:latin typeface="Calibri"/>
+              </a:rPr>
+              <a:t>S</a:t>
+            </a:r>
+            <a:r>
+              <a:rPr sz="2400" b="1">
+                <a:solidFill>
+                  <a:srgbClr val="991B1B"/>
+                </a:solidFill>
+                <a:latin typeface="Calibri"/>
+              </a:rPr>
+              <a:t>T = S \ T</a:t>
             </a:r>
           </a:p>
         </p:txBody>
       </p:sp>
       <p:pic>
         <p:nvPicPr>
-          <p:cNvPr id="6" name="Picture 5" descr="rId21.png"/>
+          <p:cNvPr id="9" name="Picture 8" descr="rId19.png"/>
           <p:cNvPicPr>
             <a:picLocks noChangeAspect="1"/>
           </p:cNvPicPr>
@@ -6514,8 +7150,8 @@
         </p:blipFill>
         <p:spPr>
           <a:xfrm>
-            <a:off x="2452400" y="1417320"/>
-            <a:ext cx="7256720" cy="4800600"/>
+            <a:off x="7840893" y="1463040"/>
+            <a:ext cx="3520614" cy="4709160"/>
           </a:xfrm>
           <a:prstGeom prst="rect">
             <a:avLst/>
@@ -6933,7 +7569,7 @@
         <p:spPr>
           <a:xfrm>
             <a:off x="731520" y="274320"/>
-            <a:ext cx="10972800" cy="868680"/>
+            <a:ext cx="9848088" cy="868680"/>
           </a:xfrm>
           <a:prstGeom prst="rect">
             <a:avLst/>
@@ -6953,7 +7589,7 @@
                 </a:solidFill>
                 <a:latin typeface="Arial"/>
               </a:rPr>
-              <a:t>BÀI TẬP CỦA BẠN</a:t>
+              <a:t>VẬN DỤNG: ĐẾM SỐ PHẦN TỬ</a:t>
             </a:r>
           </a:p>
         </p:txBody>
@@ -7032,91 +7668,21 @@
                 </a:solidFill>
                 <a:latin typeface="Calibri"/>
               </a:rPr>
-              <a:t>Toán 10 · Bài 2. Tập hợp và các phép toán trên tập hợp          26</a:t>
-            </a:r>
-          </a:p>
-        </p:txBody>
-      </p:sp>
-      <p:sp>
-        <p:nvSpPr>
-          <p:cNvPr id="6" name="Rectangle 5"/>
-          <p:cNvSpPr/>
-          <p:nvPr/>
-        </p:nvSpPr>
-        <p:spPr>
-          <a:xfrm>
-            <a:off x="731520" y="1463040"/>
-            <a:ext cx="4572000" cy="4572000"/>
-          </a:xfrm>
-          <a:prstGeom prst="rect">
-            <a:avLst/>
-          </a:prstGeom>
-          <a:solidFill>
-            <a:srgbClr val="F8FAFC"/>
-          </a:solidFill>
-          <a:ln w="19050">
-            <a:solidFill>
-              <a:srgbClr val="E2E8F0"/>
-            </a:solidFill>
-          </a:ln>
-          <a:effectLst/>
-        </p:spPr>
-        <p:style>
-          <a:lnRef idx="1">
-            <a:schemeClr val="accent1"/>
-          </a:lnRef>
-          <a:fillRef idx="3">
-            <a:schemeClr val="accent1"/>
-          </a:fillRef>
-          <a:effectRef idx="2">
-            <a:schemeClr val="accent1"/>
-          </a:effectRef>
-          <a:fontRef idx="minor">
-            <a:schemeClr val="lt1"/>
-          </a:fontRef>
-        </p:style>
-        <p:txBody>
-          <a:bodyPr rtlCol="0" anchor="ctr"/>
-          <a:lstStyle/>
-          <a:p>
-            <a:pPr algn="ctr"/>
-          </a:p>
-        </p:txBody>
-      </p:sp>
-      <p:pic>
-        <p:nvPicPr>
-          <p:cNvPr id="7" name="Picture 6" descr="QR_CungCo_Bai2_Toan10.png"/>
-          <p:cNvPicPr>
-            <a:picLocks noChangeAspect="1"/>
-          </p:cNvPicPr>
-          <p:nvPr/>
-        </p:nvPicPr>
-        <p:blipFill>
-          <a:blip r:embed="rId2"/>
-          <a:stretch>
-            <a:fillRect/>
-          </a:stretch>
-        </p:blipFill>
-        <p:spPr>
-          <a:xfrm>
-            <a:off x="960120" y="1691640"/>
-            <a:ext cx="4114800" cy="4114800"/>
-          </a:xfrm>
-          <a:prstGeom prst="rect">
-            <a:avLst/>
-          </a:prstGeom>
-        </p:spPr>
-      </p:pic>
-      <p:sp>
-        <p:nvSpPr>
-          <p:cNvPr id="8" name="TextBox 7"/>
+              <a:t>Toán 10 · Bài 2. Tập hợp và các phép toán trên tập hợp          20</a:t>
+            </a:r>
+          </a:p>
+        </p:txBody>
+      </p:sp>
+      <p:sp>
+        <p:nvSpPr>
+          <p:cNvPr id="6" name="TextBox 5"/>
           <p:cNvSpPr txBox="1"/>
           <p:nvPr/>
         </p:nvSpPr>
         <p:spPr>
           <a:xfrm>
-            <a:off x="5760720" y="1554480"/>
-            <a:ext cx="6035040" cy="3108960"/>
+            <a:off x="731520" y="1508760"/>
+            <a:ext cx="10789920" cy="2834640"/>
           </a:xfrm>
           <a:prstGeom prst="rect">
             <a:avLst/>
@@ -7140,13 +7706,13 @@
               <a:buChar char="•"/>
             </a:pPr>
             <a:r>
-              <a:rPr sz="2600">
+              <a:rPr sz="2400">
                 <a:solidFill>
                   <a:srgbClr val="1E293B"/>
                 </a:solidFill>
                 <a:latin typeface="Calibri"/>
               </a:rPr>
-              <a:t>Quét mã QR bằng điện thoại</a:t>
+              <a:t>Lớp 10A: 24 bạn thi đấu</a:t>
             </a:r>
           </a:p>
           <a:p>
@@ -7161,13 +7727,13 @@
               <a:buChar char="•"/>
             </a:pPr>
             <a:r>
-              <a:rPr sz="2600">
+              <a:rPr sz="2400">
                 <a:solidFill>
                   <a:srgbClr val="1E293B"/>
                 </a:solidFill>
                 <a:latin typeface="Calibri"/>
               </a:rPr>
-              <a:t>Nhập họ tên và lớp</a:t>
+              <a:t>Bóng đá 16 bạn, cầu lông 11 bạn</a:t>
             </a:r>
           </a:p>
           <a:p>
@@ -7182,13 +7748,13 @@
               <a:buChar char="•"/>
             </a:pPr>
             <a:r>
-              <a:rPr sz="2600">
+              <a:rPr sz="2400">
                 <a:solidFill>
                   <a:srgbClr val="1E293B"/>
                 </a:solidFill>
                 <a:latin typeface="Calibri"/>
               </a:rPr>
-              <a:t>7 câu – làm trong 7 phút</a:t>
+              <a:t>Mỗi bạn thi ít nhất một môn</a:t>
             </a:r>
           </a:p>
           <a:p>
@@ -7203,38 +7769,15 @@
               <a:buChar char="•"/>
             </a:pPr>
             <a:r>
-              <a:rPr sz="2600">
+              <a:rPr sz="2400">
                 <a:solidFill>
                   <a:srgbClr val="1E293B"/>
                 </a:solidFill>
                 <a:latin typeface="Calibri"/>
               </a:rPr>
-              <a:t>Nộp bài, xem lời giải</a:t>
-            </a:r>
-          </a:p>
-        </p:txBody>
-      </p:sp>
-      <p:sp>
-        <p:nvSpPr>
-          <p:cNvPr id="9" name="TextBox 8"/>
-          <p:cNvSpPr txBox="1"/>
-          <p:nvPr/>
-        </p:nvSpPr>
-        <p:spPr>
-          <a:xfrm>
-            <a:off x="5760720" y="4754880"/>
-            <a:ext cx="6035040" cy="1188720"/>
-          </a:xfrm>
-          <a:prstGeom prst="rect">
-            <a:avLst/>
-          </a:prstGeom>
-          <a:noFill/>
-        </p:spPr>
-        <p:txBody>
-          <a:bodyPr wrap="square" anchor="t">
-            <a:spAutoFit/>
-          </a:bodyPr>
-          <a:lstStyle/>
+              <a:t>Bao nhiêu bạn thi cả hai môn?</a:t>
+            </a:r>
+          </a:p>
           <a:p>
             <a:pPr algn="l">
               <a:spcAft>
@@ -7242,14 +7785,66 @@
               </a:spcAft>
             </a:pPr>
             <a:r>
-              <a:rPr sz="1800" b="1">
+              <a:rPr sz="2400" b="1">
                 <a:solidFill>
                   <a:srgbClr val="1E40AF"/>
                 </a:solidFill>
                 <a:latin typeface="Calibri"/>
-                <a:hlinkClick r:id="rId3"/>
-              </a:rPr>
-              <a:t>trangtu66.github.io/Taode_thi_online/cc_bai2_t10.html</a:t>
+              </a:rPr>
+              <a:t>Gợi mở: Vẽ biểu đồ Ven</a:t>
+            </a:r>
+          </a:p>
+        </p:txBody>
+      </p:sp>
+      <p:sp>
+        <p:nvSpPr>
+          <p:cNvPr id="7" name="Rounded Rectangle 6"/>
+          <p:cNvSpPr/>
+          <p:nvPr/>
+        </p:nvSpPr>
+        <p:spPr>
+          <a:xfrm>
+            <a:off x="10701223" y="457200"/>
+            <a:ext cx="941832" cy="457200"/>
+          </a:xfrm>
+          <a:prstGeom prst="roundRect">
+            <a:avLst/>
+          </a:prstGeom>
+          <a:solidFill>
+            <a:srgbClr val="1E40AF"/>
+          </a:solidFill>
+          <a:ln>
+            <a:noFill/>
+          </a:ln>
+          <a:effectLst/>
+        </p:spPr>
+        <p:style>
+          <a:lnRef idx="1">
+            <a:schemeClr val="accent1"/>
+          </a:lnRef>
+          <a:fillRef idx="3">
+            <a:schemeClr val="accent1"/>
+          </a:fillRef>
+          <a:effectRef idx="2">
+            <a:schemeClr val="accent1"/>
+          </a:effectRef>
+          <a:fontRef idx="minor">
+            <a:schemeClr val="lt1"/>
+          </a:fontRef>
+        </p:style>
+        <p:txBody>
+          <a:bodyPr rtlCol="0" anchor="ctr" tIns="0" bIns="0"/>
+          <a:lstStyle/>
+          <a:p>
+            <a:pPr algn="ctr"/>
+            <a:r>
+              <a:rPr sz="1400" b="1">
+                <a:solidFill>
+                  <a:srgbClr val="FFFFFF"/>
+                </a:solidFill>
+                <a:latin typeface="Arial"/>
+              </a:rPr>
+              <a:t>ĐỀ BÀI</a:t>
             </a:r>
           </a:p>
         </p:txBody>
@@ -7333,7 +7928,7 @@
         <p:spPr>
           <a:xfrm>
             <a:off x="731520" y="274320"/>
-            <a:ext cx="10972800" cy="868680"/>
+            <a:ext cx="9610344" cy="868680"/>
           </a:xfrm>
           <a:prstGeom prst="rect">
             <a:avLst/>
@@ -7353,7 +7948,7 @@
                 </a:solidFill>
                 <a:latin typeface="Arial"/>
               </a:rPr>
-              <a:t>TRẠM KIỂM CHỨNG AI – LỜI GIẢI</a:t>
+              <a:t>VẬN DỤNG: ĐẾM SỐ PHẦN TỬ</a:t>
             </a:r>
           </a:p>
         </p:txBody>
@@ -7432,7 +8027,7 @@
                 </a:solidFill>
                 <a:latin typeface="Calibri"/>
               </a:rPr>
-              <a:t>Toán 10 · Bài 2. Tập hợp và các phép toán trên tập hợp          23</a:t>
+              <a:t>Toán 10 · Bài 2. Tập hợp và các phép toán trên tập hợp          21</a:t>
             </a:r>
           </a:p>
         </p:txBody>
@@ -7446,7 +8041,7 @@
         <p:spPr>
           <a:xfrm>
             <a:off x="731520" y="1508760"/>
-            <a:ext cx="10789920" cy="2267712"/>
+            <a:ext cx="10789920" cy="1700784"/>
           </a:xfrm>
           <a:prstGeom prst="rect">
             <a:avLst/>
@@ -7458,6 +8053,22 @@
             <a:spAutoFit/>
           </a:bodyPr>
           <a:lstStyle/>
+          <a:p>
+            <a:pPr algn="l">
+              <a:spcAft>
+                <a:spcPts val="1000"/>
+              </a:spcAft>
+            </a:pPr>
+            <a:r>
+              <a:rPr sz="2400" b="1">
+                <a:solidFill>
+                  <a:srgbClr val="1E40AF"/>
+                </a:solidFill>
+                <a:latin typeface="Calibri"/>
+              </a:rPr>
+              <a:t>Lớp 10A: 24 bạn thi đấu</a:t>
+            </a:r>
+          </a:p>
           <a:p>
             <a:pPr algn="l" marL="365760" indent="-365760">
               <a:spcAft>
@@ -7476,7 +8087,7 @@
                 </a:solidFill>
                 <a:latin typeface="Calibri"/>
               </a:rPr>
-              <a:t>Nhầm ∈ với ⊂</a:t>
+              <a:t>Bóng đá 16 bạn, cầu lông 11 bạn</a:t>
             </a:r>
           </a:p>
           <a:p>
@@ -7497,49 +8108,7 @@
                 </a:solidFill>
                 <a:latin typeface="Calibri"/>
               </a:rPr>
-              <a:t>Sai đầu mút khi lấy giao, hợp</a:t>
-            </a:r>
-          </a:p>
-          <a:p>
-            <a:pPr algn="l" marL="365760" indent="-365760">
-              <a:spcAft>
-                <a:spcPts val="1000"/>
-              </a:spcAft>
-              <a:buClr>
-                <a:srgbClr val="1E40AF"/>
-              </a:buClr>
-              <a:buFont typeface="Arial"/>
-              <a:buChar char="•"/>
-            </a:pPr>
-            <a:r>
-              <a:rPr sz="2400">
-                <a:solidFill>
-                  <a:srgbClr val="1E293B"/>
-                </a:solidFill>
-                <a:latin typeface="Calibri"/>
-              </a:rPr>
-              <a:t>Đếm trùng khi tính n(A ∪ B)</a:t>
-            </a:r>
-          </a:p>
-          <a:p>
-            <a:pPr algn="l" marL="365760" indent="-365760">
-              <a:spcAft>
-                <a:spcPts val="1000"/>
-              </a:spcAft>
-              <a:buClr>
-                <a:srgbClr val="1E40AF"/>
-              </a:buClr>
-              <a:buFont typeface="Arial"/>
-              <a:buChar char="•"/>
-            </a:pPr>
-            <a:r>
-              <a:rPr sz="2400">
-                <a:solidFill>
-                  <a:srgbClr val="1E293B"/>
-                </a:solidFill>
-                <a:latin typeface="Calibri"/>
-              </a:rPr>
-              <a:t>Hỏi AI: (−2; 1] ∩ (1; +∞) = ?</a:t>
+              <a:t>24 = 16 + 11 − x  ⇒  x = 3</a:t>
             </a:r>
           </a:p>
         </p:txBody>
@@ -7552,7 +8121,7 @@
         </p:nvSpPr>
         <p:spPr>
           <a:xfrm>
-            <a:off x="731520" y="3913632"/>
+            <a:off x="731520" y="3346704"/>
             <a:ext cx="8686800" cy="685800"/>
           </a:xfrm>
           <a:prstGeom prst="roundRect">
@@ -7600,7 +8169,7 @@
         </p:nvSpPr>
         <p:spPr>
           <a:xfrm>
-            <a:off x="914400" y="3913632"/>
+            <a:off x="914400" y="3346704"/>
             <a:ext cx="8321040" cy="685800"/>
           </a:xfrm>
           <a:prstGeom prst="rect">
@@ -7626,7 +8195,84 @@
                 </a:solidFill>
                 <a:latin typeface="Calibri"/>
               </a:rPr>
-              <a:t>Kiểm chứng bằng trục số, Ven</a:t>
+              <a:t>n(A ∪ B) = n(A) + n(B) − n(A ∩ B)</a:t>
+            </a:r>
+          </a:p>
+        </p:txBody>
+      </p:sp>
+      <p:pic>
+        <p:nvPicPr>
+          <p:cNvPr id="9" name="Picture 8" descr="rId20.png"/>
+          <p:cNvPicPr>
+            <a:picLocks noChangeAspect="1"/>
+          </p:cNvPicPr>
+          <p:nvPr/>
+        </p:nvPicPr>
+        <p:blipFill>
+          <a:blip r:embed="rId2"/>
+          <a:stretch>
+            <a:fillRect/>
+          </a:stretch>
+        </p:blipFill>
+        <p:spPr>
+          <a:xfrm>
+            <a:off x="2577164" y="4169664"/>
+            <a:ext cx="7007191" cy="2048255"/>
+          </a:xfrm>
+          <a:prstGeom prst="rect">
+            <a:avLst/>
+          </a:prstGeom>
+        </p:spPr>
+      </p:pic>
+      <p:sp>
+        <p:nvSpPr>
+          <p:cNvPr id="10" name="Rounded Rectangle 9"/>
+          <p:cNvSpPr/>
+          <p:nvPr/>
+        </p:nvSpPr>
+        <p:spPr>
+          <a:xfrm>
+            <a:off x="10463479" y="457200"/>
+            <a:ext cx="1179576" cy="457200"/>
+          </a:xfrm>
+          <a:prstGeom prst="roundRect">
+            <a:avLst/>
+          </a:prstGeom>
+          <a:solidFill>
+            <a:srgbClr val="166534"/>
+          </a:solidFill>
+          <a:ln>
+            <a:noFill/>
+          </a:ln>
+          <a:effectLst/>
+        </p:spPr>
+        <p:style>
+          <a:lnRef idx="1">
+            <a:schemeClr val="accent1"/>
+          </a:lnRef>
+          <a:fillRef idx="3">
+            <a:schemeClr val="accent1"/>
+          </a:fillRef>
+          <a:effectRef idx="2">
+            <a:schemeClr val="accent1"/>
+          </a:effectRef>
+          <a:fontRef idx="minor">
+            <a:schemeClr val="lt1"/>
+          </a:fontRef>
+        </p:style>
+        <p:txBody>
+          <a:bodyPr rtlCol="0" anchor="ctr" tIns="0" bIns="0"/>
+          <a:lstStyle/>
+          <a:p>
+            <a:pPr algn="ctr"/>
+            <a:r>
+              <a:rPr sz="1400" b="1">
+                <a:solidFill>
+                  <a:srgbClr val="FFFFFF"/>
+                </a:solidFill>
+                <a:latin typeface="Arial"/>
+              </a:rPr>
+              <a:t>LỜI GIẢI</a:t>
             </a:r>
           </a:p>
         </p:txBody>
@@ -7710,7 +8356,7 @@
         <p:spPr>
           <a:xfrm>
             <a:off x="731520" y="274320"/>
-            <a:ext cx="10972800" cy="868680"/>
+            <a:ext cx="9848088" cy="868680"/>
           </a:xfrm>
           <a:prstGeom prst="rect">
             <a:avLst/>
@@ -7730,7 +8376,7 @@
                 </a:solidFill>
                 <a:latin typeface="Arial"/>
               </a:rPr>
-              <a:t>VẬN DỤNG: ĐẾM SỐ PHẦN TỬ – LỜI GIẢI</a:t>
+              <a:t>TRẠM KIỂM CHỨNG AI</a:t>
             </a:r>
           </a:p>
         </p:txBody>
@@ -7809,7 +8455,7 @@
                 </a:solidFill>
                 <a:latin typeface="Calibri"/>
               </a:rPr>
-              <a:t>Toán 10 · Bài 2. Tập hợp và các phép toán trên tập hợp          21</a:t>
+              <a:t>Toán 10 · Bài 2. Tập hợp và các phép toán trên tập hợp          22</a:t>
             </a:r>
           </a:p>
         </p:txBody>
@@ -7835,22 +8481,6 @@
             <a:spAutoFit/>
           </a:bodyPr>
           <a:lstStyle/>
-          <a:p>
-            <a:pPr algn="l">
-              <a:spcAft>
-                <a:spcPts val="1000"/>
-              </a:spcAft>
-            </a:pPr>
-            <a:r>
-              <a:rPr sz="2400" b="1">
-                <a:solidFill>
-                  <a:srgbClr val="1E40AF"/>
-                </a:solidFill>
-                <a:latin typeface="Calibri"/>
-              </a:rPr>
-              <a:t>Lớp 10A: 24 bạn thi đấu</a:t>
-            </a:r>
-          </a:p>
           <a:p>
             <a:pPr algn="l" marL="365760" indent="-365760">
               <a:spcAft>
@@ -7869,7 +8499,7 @@
                 </a:solidFill>
                 <a:latin typeface="Calibri"/>
               </a:rPr>
-              <a:t>Bóng đá 16 bạn, cầu lông 11 bạn</a:t>
+              <a:t>Hỏi AI: (−2; 1] ∩ (1; +∞) = ?</a:t>
             </a:r>
           </a:p>
           <a:p>
@@ -7890,7 +8520,23 @@
                 </a:solidFill>
                 <a:latin typeface="Calibri"/>
               </a:rPr>
-              <a:t>24 = 16 + 11 − x  ⇒  x = 3</a:t>
+              <a:t>Đối chiếu câu trả lời của AI</a:t>
+            </a:r>
+          </a:p>
+          <a:p>
+            <a:pPr algn="l">
+              <a:spcAft>
+                <a:spcPts val="1000"/>
+              </a:spcAft>
+            </a:pPr>
+            <a:r>
+              <a:rPr sz="2400" b="1">
+                <a:solidFill>
+                  <a:srgbClr val="1E40AF"/>
+                </a:solidFill>
+                <a:latin typeface="Calibri"/>
+              </a:rPr>
+              <a:t>Gợi mở: Tìm bước sai, giải thích, sửa lại</a:t>
             </a:r>
           </a:p>
         </p:txBody>
@@ -7903,21 +8549,17 @@
         </p:nvSpPr>
         <p:spPr>
           <a:xfrm>
-            <a:off x="731520" y="3346704"/>
-            <a:ext cx="8686800" cy="685800"/>
+            <a:off x="10701223" y="457200"/>
+            <a:ext cx="941832" cy="457200"/>
           </a:xfrm>
           <a:prstGeom prst="roundRect">
-            <a:avLst>
-              <a:gd name="adj" fmla="val 8000"/>
-            </a:avLst>
+            <a:avLst/>
           </a:prstGeom>
           <a:solidFill>
-            <a:srgbClr val="FEF2F2"/>
+            <a:srgbClr val="1E40AF"/>
           </a:solidFill>
-          <a:ln w="19050">
-            <a:solidFill>
-              <a:srgbClr val="991B1B"/>
-            </a:solidFill>
+          <a:ln>
+            <a:noFill/>
           </a:ln>
           <a:effectLst/>
         </p:spPr>
@@ -7936,76 +8578,22 @@
           </a:fontRef>
         </p:style>
         <p:txBody>
-          <a:bodyPr rtlCol="0" anchor="ctr"/>
+          <a:bodyPr rtlCol="0" anchor="ctr" tIns="0" bIns="0"/>
           <a:lstStyle/>
           <a:p>
             <a:pPr algn="ctr"/>
-          </a:p>
-        </p:txBody>
-      </p:sp>
-      <p:sp>
-        <p:nvSpPr>
-          <p:cNvPr id="8" name="TextBox 7"/>
-          <p:cNvSpPr txBox="1"/>
-          <p:nvPr/>
-        </p:nvSpPr>
-        <p:spPr>
-          <a:xfrm>
-            <a:off x="914400" y="3346704"/>
-            <a:ext cx="8321040" cy="685800"/>
-          </a:xfrm>
-          <a:prstGeom prst="rect">
-            <a:avLst/>
-          </a:prstGeom>
-          <a:noFill/>
-        </p:spPr>
-        <p:txBody>
-          <a:bodyPr wrap="square" anchor="ctr">
-            <a:spAutoFit/>
-          </a:bodyPr>
-          <a:lstStyle/>
-          <a:p>
-            <a:pPr algn="l">
-              <a:spcAft>
-                <a:spcPts val="400"/>
-              </a:spcAft>
-            </a:pPr>
-            <a:r>
-              <a:rPr sz="2400" b="1">
-                <a:solidFill>
-                  <a:srgbClr val="991B1B"/>
-                </a:solidFill>
-                <a:latin typeface="Calibri"/>
-              </a:rPr>
-              <a:t>n(A ∪ B) = n(A) + n(B) − n(A ∩ B)</a:t>
-            </a:r>
-          </a:p>
-        </p:txBody>
-      </p:sp>
-      <p:pic>
-        <p:nvPicPr>
-          <p:cNvPr id="9" name="Picture 8" descr="rId20.png"/>
-          <p:cNvPicPr>
-            <a:picLocks noChangeAspect="1"/>
-          </p:cNvPicPr>
-          <p:nvPr/>
-        </p:nvPicPr>
-        <p:blipFill>
-          <a:blip r:embed="rId2"/>
-          <a:stretch>
-            <a:fillRect/>
-          </a:stretch>
-        </p:blipFill>
-        <p:spPr>
-          <a:xfrm>
-            <a:off x="2577164" y="4169664"/>
-            <a:ext cx="7007191" cy="2048255"/>
-          </a:xfrm>
-          <a:prstGeom prst="rect">
-            <a:avLst/>
-          </a:prstGeom>
-        </p:spPr>
-      </p:pic>
+            <a:r>
+              <a:rPr sz="1400" b="1">
+                <a:solidFill>
+                  <a:srgbClr val="FFFFFF"/>
+                </a:solidFill>
+                <a:latin typeface="Arial"/>
+              </a:rPr>
+              <a:t>ĐỀ BÀI</a:t>
+            </a:r>
+          </a:p>
+        </p:txBody>
+      </p:sp>
     </p:spTree>
   </p:cSld>
   <p:clrMapOvr>
@@ -8085,7 +8673,7 @@
         <p:spPr>
           <a:xfrm>
             <a:off x="731520" y="274320"/>
-            <a:ext cx="10972800" cy="868680"/>
+            <a:ext cx="9610344" cy="868680"/>
           </a:xfrm>
           <a:prstGeom prst="rect">
             <a:avLst/>
@@ -8105,7 +8693,7 @@
                 </a:solidFill>
                 <a:latin typeface="Arial"/>
               </a:rPr>
-              <a:t>KHỞI ĐỘNG – LỜI GIẢI</a:t>
+              <a:t>TRẠM KIỂM CHỨNG AI</a:t>
             </a:r>
           </a:p>
         </p:txBody>
@@ -8184,7 +8772,7 @@
                 </a:solidFill>
                 <a:latin typeface="Calibri"/>
               </a:rPr>
-              <a:t>Toán 10 · Bài 2. Tập hợp và các phép toán trên tập hợp          18</a:t>
+              <a:t>Toán 10 · Bài 2. Tập hợp và các phép toán trên tập hợp          23</a:t>
             </a:r>
           </a:p>
         </p:txBody>
@@ -8198,7 +8786,7 @@
         <p:spPr>
           <a:xfrm>
             <a:off x="731520" y="1508760"/>
-            <a:ext cx="10789920" cy="1700784"/>
+            <a:ext cx="10789920" cy="2267712"/>
           </a:xfrm>
           <a:prstGeom prst="rect">
             <a:avLst/>
@@ -8228,7 +8816,7 @@
                 </a:solidFill>
                 <a:latin typeface="Calibri"/>
               </a:rPr>
-              <a:t>A: 7 bạn dự Chuyên đề 1</a:t>
+              <a:t>Nhầm ∈ với ⊂</a:t>
             </a:r>
           </a:p>
           <a:p>
@@ -8249,7 +8837,7 @@
                 </a:solidFill>
                 <a:latin typeface="Calibri"/>
               </a:rPr>
-              <a:t>B: 8 bạn dự Chuyên đề 2</a:t>
+              <a:t>Sai đầu mút khi lấy giao, hợp</a:t>
             </a:r>
           </a:p>
           <a:p>
@@ -8270,7 +8858,28 @@
                 </a:solidFill>
                 <a:latin typeface="Calibri"/>
               </a:rPr>
-              <a:t>A ∪ B có 10 phần tử</a:t>
+              <a:t>Đếm trùng khi tính n(A ∪ B)</a:t>
+            </a:r>
+          </a:p>
+          <a:p>
+            <a:pPr algn="l" marL="365760" indent="-365760">
+              <a:spcAft>
+                <a:spcPts val="1000"/>
+              </a:spcAft>
+              <a:buClr>
+                <a:srgbClr val="1E40AF"/>
+              </a:buClr>
+              <a:buFont typeface="Arial"/>
+              <a:buChar char="•"/>
+            </a:pPr>
+            <a:r>
+              <a:rPr sz="2400">
+                <a:solidFill>
+                  <a:srgbClr val="1E293B"/>
+                </a:solidFill>
+                <a:latin typeface="Calibri"/>
+              </a:rPr>
+              <a:t>Hỏi AI: (−2; 1] ∩ (1; +∞) = ?</a:t>
             </a:r>
           </a:p>
         </p:txBody>
@@ -8283,7 +8892,7 @@
         </p:nvSpPr>
         <p:spPr>
           <a:xfrm>
-            <a:off x="731520" y="3346704"/>
+            <a:off x="731520" y="3913632"/>
             <a:ext cx="8686800" cy="685800"/>
           </a:xfrm>
           <a:prstGeom prst="roundRect">
@@ -8331,7 +8940,7 @@
         </p:nvSpPr>
         <p:spPr>
           <a:xfrm>
-            <a:off x="914400" y="3346704"/>
+            <a:off x="914400" y="3913632"/>
             <a:ext cx="8321040" cy="685800"/>
           </a:xfrm>
           <a:prstGeom prst="rect">
@@ -8357,35 +8966,64 @@
                 </a:solidFill>
                 <a:latin typeface="Calibri"/>
               </a:rPr>
-              <a:t>Vắng cả hai: 12 − 10 = 2 bạn</a:t>
-            </a:r>
-          </a:p>
-        </p:txBody>
-      </p:sp>
-      <p:pic>
-        <p:nvPicPr>
-          <p:cNvPr id="9" name="Picture 8" descr="rId9.png"/>
-          <p:cNvPicPr>
-            <a:picLocks noChangeAspect="1"/>
-          </p:cNvPicPr>
-          <p:nvPr/>
-        </p:nvPicPr>
-        <p:blipFill>
-          <a:blip r:embed="rId2"/>
-          <a:stretch>
-            <a:fillRect/>
-          </a:stretch>
-        </p:blipFill>
-        <p:spPr>
-          <a:xfrm>
-            <a:off x="4023291" y="4169664"/>
-            <a:ext cx="4114937" cy="2048256"/>
-          </a:xfrm>
-          <a:prstGeom prst="rect">
-            <a:avLst/>
-          </a:prstGeom>
-        </p:spPr>
-      </p:pic>
+              <a:t>Kiểm chứng bằng trục số, Ven</a:t>
+            </a:r>
+          </a:p>
+        </p:txBody>
+      </p:sp>
+      <p:sp>
+        <p:nvSpPr>
+          <p:cNvPr id="9" name="Rounded Rectangle 8"/>
+          <p:cNvSpPr/>
+          <p:nvPr/>
+        </p:nvSpPr>
+        <p:spPr>
+          <a:xfrm>
+            <a:off x="10463479" y="457200"/>
+            <a:ext cx="1179576" cy="457200"/>
+          </a:xfrm>
+          <a:prstGeom prst="roundRect">
+            <a:avLst/>
+          </a:prstGeom>
+          <a:solidFill>
+            <a:srgbClr val="166534"/>
+          </a:solidFill>
+          <a:ln>
+            <a:noFill/>
+          </a:ln>
+          <a:effectLst/>
+        </p:spPr>
+        <p:style>
+          <a:lnRef idx="1">
+            <a:schemeClr val="accent1"/>
+          </a:lnRef>
+          <a:fillRef idx="3">
+            <a:schemeClr val="accent1"/>
+          </a:fillRef>
+          <a:effectRef idx="2">
+            <a:schemeClr val="accent1"/>
+          </a:effectRef>
+          <a:fontRef idx="minor">
+            <a:schemeClr val="lt1"/>
+          </a:fontRef>
+        </p:style>
+        <p:txBody>
+          <a:bodyPr rtlCol="0" anchor="ctr" tIns="0" bIns="0"/>
+          <a:lstStyle/>
+          <a:p>
+            <a:pPr algn="ctr"/>
+            <a:r>
+              <a:rPr sz="1400" b="1">
+                <a:solidFill>
+                  <a:srgbClr val="FFFFFF"/>
+                </a:solidFill>
+                <a:latin typeface="Arial"/>
+              </a:rPr>
+              <a:t>LỜI GIẢI</a:t>
+            </a:r>
+          </a:p>
+        </p:txBody>
+      </p:sp>
     </p:spTree>
   </p:cSld>
   <p:clrMapOvr>
@@ -8485,7 +9123,7 @@
                 </a:solidFill>
                 <a:latin typeface="Arial"/>
               </a:rPr>
-              <a:t>VÍ DỤ 5: KHOẢNG, ĐOẠN – LỜI GIẢI</a:t>
+              <a:t>VỀ NHÀ: LỚP MÌNH QUA BIỂU ĐỒ VEN</a:t>
             </a:r>
           </a:p>
         </p:txBody>
@@ -8564,7 +9202,7 @@
                 </a:solidFill>
                 <a:latin typeface="Calibri"/>
               </a:rPr>
-              <a:t>Toán 10 · Bài 2. Tập hợp và các phép toán trên tập hợp          14</a:t>
+              <a:t>Toán 10 · Bài 2. Tập hợp và các phép toán trên tập hợp          24</a:t>
             </a:r>
           </a:p>
         </p:txBody>
@@ -8578,7 +9216,7 @@
         <p:spPr>
           <a:xfrm>
             <a:off x="731520" y="1508760"/>
-            <a:ext cx="10789920" cy="1133856"/>
+            <a:ext cx="10789920" cy="2834640"/>
           </a:xfrm>
           <a:prstGeom prst="rect">
             <a:avLst/>
@@ -8608,7 +9246,7 @@
                 </a:solidFill>
                 <a:latin typeface="Calibri"/>
               </a:rPr>
-              <a:t>C = {x ∈ ℝ | 2 ≤ x ≤ 7} = [2; 7]</a:t>
+              <a:t>Tạo Google Forms 2 câu Có/Không</a:t>
             </a:r>
           </a:p>
           <a:p>
@@ -8629,122 +9267,74 @@
                 </a:solidFill>
                 <a:latin typeface="Calibri"/>
               </a:rPr>
-              <a:t>D = {x ∈ ℝ | x &lt; 2} = (−∞; 2)</a:t>
-            </a:r>
-          </a:p>
-        </p:txBody>
-      </p:sp>
-      <p:sp>
-        <p:nvSpPr>
-          <p:cNvPr id="7" name="Rounded Rectangle 6"/>
-          <p:cNvSpPr/>
-          <p:nvPr/>
-        </p:nvSpPr>
-        <p:spPr>
-          <a:xfrm>
-            <a:off x="731520" y="2779776"/>
-            <a:ext cx="8686800" cy="685800"/>
-          </a:xfrm>
-          <a:prstGeom prst="roundRect">
-            <a:avLst>
-              <a:gd name="adj" fmla="val 8000"/>
-            </a:avLst>
-          </a:prstGeom>
-          <a:solidFill>
-            <a:srgbClr val="FEF2F2"/>
-          </a:solidFill>
-          <a:ln w="19050">
-            <a:solidFill>
-              <a:srgbClr val="991B1B"/>
-            </a:solidFill>
-          </a:ln>
-          <a:effectLst/>
-        </p:spPr>
-        <p:style>
-          <a:lnRef idx="1">
-            <a:schemeClr val="accent1"/>
-          </a:lnRef>
-          <a:fillRef idx="3">
-            <a:schemeClr val="accent1"/>
-          </a:fillRef>
-          <a:effectRef idx="2">
-            <a:schemeClr val="accent1"/>
-          </a:effectRef>
-          <a:fontRef idx="minor">
-            <a:schemeClr val="lt1"/>
-          </a:fontRef>
-        </p:style>
-        <p:txBody>
-          <a:bodyPr rtlCol="0" anchor="ctr"/>
-          <a:lstStyle/>
-          <a:p>
-            <a:pPr algn="ctr"/>
-          </a:p>
-        </p:txBody>
-      </p:sp>
-      <p:sp>
-        <p:nvSpPr>
-          <p:cNvPr id="8" name="TextBox 7"/>
-          <p:cNvSpPr txBox="1"/>
-          <p:nvPr/>
-        </p:nvSpPr>
-        <p:spPr>
-          <a:xfrm>
-            <a:off x="914400" y="2779776"/>
-            <a:ext cx="8321040" cy="685800"/>
-          </a:xfrm>
-          <a:prstGeom prst="rect">
-            <a:avLst/>
-          </a:prstGeom>
-          <a:noFill/>
-        </p:spPr>
-        <p:txBody>
-          <a:bodyPr wrap="square" anchor="ctr">
-            <a:spAutoFit/>
-          </a:bodyPr>
-          <a:lstStyle/>
-          <a:p>
-            <a:pPr algn="l">
+              <a:t>Không thu họ tên, số điện thoại</a:t>
+            </a:r>
+          </a:p>
+          <a:p>
+            <a:pPr algn="l" marL="365760" indent="-365760">
               <a:spcAft>
-                <a:spcPts val="400"/>
+                <a:spcPts val="1000"/>
               </a:spcAft>
+              <a:buClr>
+                <a:srgbClr val="1E40AF"/>
+              </a:buClr>
+              <a:buFont typeface="Arial"/>
+              <a:buChar char="•"/>
             </a:pPr>
             <a:r>
-              <a:rPr sz="2400" b="1">
-                <a:solidFill>
-                  <a:srgbClr val="991B1B"/>
-                </a:solidFill>
-                <a:latin typeface="Calibri"/>
-              </a:rPr>
-              <a:t>Phần bị gạch là phần bỏ đi</a:t>
-            </a:r>
-          </a:p>
-        </p:txBody>
-      </p:sp>
-      <p:pic>
-        <p:nvPicPr>
-          <p:cNvPr id="9" name="Picture 8" descr="rId14.png"/>
-          <p:cNvPicPr>
-            <a:picLocks noChangeAspect="1"/>
-          </p:cNvPicPr>
-          <p:nvPr/>
-        </p:nvPicPr>
-        <p:blipFill>
-          <a:blip r:embed="rId2"/>
-          <a:stretch>
-            <a:fillRect/>
-          </a:stretch>
-        </p:blipFill>
-        <p:spPr>
-          <a:xfrm>
-            <a:off x="731520" y="3647875"/>
-            <a:ext cx="10698480" cy="2524906"/>
-          </a:xfrm>
-          <a:prstGeom prst="rect">
-            <a:avLst/>
-          </a:prstGeom>
-        </p:spPr>
-      </p:pic>
+              <a:rPr sz="2400">
+                <a:solidFill>
+                  <a:srgbClr val="1E293B"/>
+                </a:solidFill>
+                <a:latin typeface="Calibri"/>
+              </a:rPr>
+              <a:t>Lọc, đếm bằng Google Sheets</a:t>
+            </a:r>
+          </a:p>
+          <a:p>
+            <a:pPr algn="l" marL="365760" indent="-365760">
+              <a:spcAft>
+                <a:spcPts val="1000"/>
+              </a:spcAft>
+              <a:buClr>
+                <a:srgbClr val="1E40AF"/>
+              </a:buClr>
+              <a:buFont typeface="Arial"/>
+              <a:buChar char="•"/>
+            </a:pPr>
+            <a:r>
+              <a:rPr sz="2400">
+                <a:solidFill>
+                  <a:srgbClr val="1E293B"/>
+                </a:solidFill>
+                <a:latin typeface="Calibri"/>
+              </a:rPr>
+              <a:t>Vẽ biểu đồ Ven, thử công thức</a:t>
+            </a:r>
+          </a:p>
+          <a:p>
+            <a:pPr algn="l" marL="365760" indent="-365760">
+              <a:spcAft>
+                <a:spcPts val="1000"/>
+              </a:spcAft>
+              <a:buClr>
+                <a:srgbClr val="1E40AF"/>
+              </a:buClr>
+              <a:buFont typeface="Arial"/>
+              <a:buChar char="•"/>
+            </a:pPr>
+            <a:r>
+              <a:rPr sz="2400">
+                <a:solidFill>
+                  <a:srgbClr val="1E293B"/>
+                </a:solidFill>
+                <a:latin typeface="Calibri"/>
+              </a:rPr>
+              <a:t>Nộp 3–5 slide trên Padlet</a:t>
+            </a:r>
+          </a:p>
+        </p:txBody>
+      </p:sp>
     </p:spTree>
   </p:cSld>
   <p:clrMapOvr>
@@ -8844,7 +9434,7 @@
                 </a:solidFill>
                 <a:latin typeface="Arial"/>
               </a:rPr>
-              <a:t>VÍ DỤ 2 – LỜI GIẢI</a:t>
+              <a:t>SƠ ĐỒ TƯ DUY BÀI HỌC</a:t>
             </a:r>
           </a:p>
         </p:txBody>
@@ -8923,133 +9513,14 @@
                 </a:solidFill>
                 <a:latin typeface="Calibri"/>
               </a:rPr>
-              <a:t>Toán 10 · Bài 2. Tập hợp và các phép toán trên tập hợp          9</a:t>
-            </a:r>
-          </a:p>
-        </p:txBody>
-      </p:sp>
-      <p:sp>
-        <p:nvSpPr>
-          <p:cNvPr id="6" name="TextBox 5"/>
-          <p:cNvSpPr txBox="1"/>
-          <p:nvPr/>
-        </p:nvSpPr>
-        <p:spPr>
-          <a:xfrm>
-            <a:off x="731520" y="1508760"/>
-            <a:ext cx="10789920" cy="1133856"/>
-          </a:xfrm>
-          <a:prstGeom prst="rect">
-            <a:avLst/>
-          </a:prstGeom>
-          <a:noFill/>
-        </p:spPr>
-        <p:txBody>
-          <a:bodyPr wrap="square" anchor="t">
-            <a:spAutoFit/>
-          </a:bodyPr>
-          <a:lstStyle/>
-          <a:p>
-            <a:pPr algn="l" marL="365760" indent="-365760">
-              <a:spcAft>
-                <a:spcPts val="1000"/>
-              </a:spcAft>
-              <a:buClr>
-                <a:srgbClr val="1E40AF"/>
-              </a:buClr>
-              <a:buFont typeface="Arial"/>
-              <a:buChar char="•"/>
-            </a:pPr>
-            <a:r>
-              <a:rPr sz="2400">
-                <a:solidFill>
-                  <a:srgbClr val="1E293B"/>
-                </a:solidFill>
-                <a:latin typeface="Calibri"/>
-              </a:rPr>
-              <a:t>S</a:t>
-            </a:r>
-            <a:r>
-              <a:rPr sz="2400" baseline="-25000">
-                <a:solidFill>
-                  <a:srgbClr val="1E293B"/>
-                </a:solidFill>
-                <a:latin typeface="Calibri"/>
-              </a:rPr>
-              <a:t>1</a:t>
-            </a:r>
-            <a:r>
-              <a:rPr sz="2400">
-                <a:solidFill>
-                  <a:srgbClr val="1E293B"/>
-                </a:solidFill>
-                <a:latin typeface="Calibri"/>
-              </a:rPr>
-              <a:t> = {3} ⊂ S;   S</a:t>
-            </a:r>
-            <a:r>
-              <a:rPr sz="2400" baseline="-25000">
-                <a:solidFill>
-                  <a:srgbClr val="1E293B"/>
-                </a:solidFill>
-                <a:latin typeface="Calibri"/>
-              </a:rPr>
-              <a:t>3</a:t>
-            </a:r>
-            <a:r>
-              <a:rPr sz="2400">
-                <a:solidFill>
-                  <a:srgbClr val="1E293B"/>
-                </a:solidFill>
-                <a:latin typeface="Calibri"/>
-              </a:rPr>
-              <a:t> = {3; 5} ⊂ S</a:t>
-            </a:r>
-          </a:p>
-          <a:p>
-            <a:pPr algn="l" marL="365760" indent="-365760">
-              <a:spcAft>
-                <a:spcPts val="1000"/>
-              </a:spcAft>
-              <a:buClr>
-                <a:srgbClr val="1E40AF"/>
-              </a:buClr>
-              <a:buFont typeface="Arial"/>
-              <a:buChar char="•"/>
-            </a:pPr>
-            <a:r>
-              <a:rPr sz="2400">
-                <a:solidFill>
-                  <a:srgbClr val="1E293B"/>
-                </a:solidFill>
-                <a:latin typeface="Calibri"/>
-              </a:rPr>
-              <a:t>S</a:t>
-            </a:r>
-            <a:r>
-              <a:rPr sz="2400" baseline="-25000">
-                <a:solidFill>
-                  <a:srgbClr val="1E293B"/>
-                </a:solidFill>
-                <a:latin typeface="Calibri"/>
-              </a:rPr>
-              <a:t>2</a:t>
-            </a:r>
-            <a:r>
-              <a:rPr sz="2400">
-                <a:solidFill>
-                  <a:srgbClr val="1E293B"/>
-                </a:solidFill>
-                <a:latin typeface="Calibri"/>
-              </a:rPr>
-              <a:t> = {0; 2} ⊄ S vì 0 ∉ S</a:t>
+              <a:t>Toán 10 · Bài 2. Tập hợp và các phép toán trên tập hợp          25</a:t>
             </a:r>
           </a:p>
         </p:txBody>
       </p:sp>
       <p:pic>
         <p:nvPicPr>
-          <p:cNvPr id="7" name="Picture 6" descr="rId11.png"/>
+          <p:cNvPr id="6" name="Picture 5" descr="rId21.png"/>
           <p:cNvPicPr>
             <a:picLocks noChangeAspect="1"/>
           </p:cNvPicPr>
@@ -9063,8 +9534,8 @@
         </p:blipFill>
         <p:spPr>
           <a:xfrm>
-            <a:off x="1065576" y="2779776"/>
-            <a:ext cx="10030368" cy="3438144"/>
+            <a:off x="2452400" y="1417320"/>
+            <a:ext cx="7256720" cy="4800600"/>
           </a:xfrm>
           <a:prstGeom prst="rect">
             <a:avLst/>
@@ -9170,7 +9641,7 @@
                 </a:solidFill>
                 <a:latin typeface="Arial"/>
               </a:rPr>
-              <a:t>VÍ DỤ 1 – LỜI GIẢI</a:t>
+              <a:t>BÀI TẬP CỦA BẠN</a:t>
             </a:r>
           </a:p>
         </p:txBody>
@@ -9249,21 +9720,91 @@
                 </a:solidFill>
                 <a:latin typeface="Calibri"/>
               </a:rPr>
-              <a:t>Toán 10 · Bài 2. Tập hợp và các phép toán trên tập hợp          6</a:t>
-            </a:r>
-          </a:p>
-        </p:txBody>
-      </p:sp>
-      <p:sp>
-        <p:nvSpPr>
-          <p:cNvPr id="6" name="TextBox 5"/>
+              <a:t>Toán 10 · Bài 2. Tập hợp và các phép toán trên tập hợp          26</a:t>
+            </a:r>
+          </a:p>
+        </p:txBody>
+      </p:sp>
+      <p:sp>
+        <p:nvSpPr>
+          <p:cNvPr id="6" name="Rectangle 5"/>
+          <p:cNvSpPr/>
+          <p:nvPr/>
+        </p:nvSpPr>
+        <p:spPr>
+          <a:xfrm>
+            <a:off x="731520" y="1463040"/>
+            <a:ext cx="4572000" cy="4572000"/>
+          </a:xfrm>
+          <a:prstGeom prst="rect">
+            <a:avLst/>
+          </a:prstGeom>
+          <a:solidFill>
+            <a:srgbClr val="F8FAFC"/>
+          </a:solidFill>
+          <a:ln w="19050">
+            <a:solidFill>
+              <a:srgbClr val="E2E8F0"/>
+            </a:solidFill>
+          </a:ln>
+          <a:effectLst/>
+        </p:spPr>
+        <p:style>
+          <a:lnRef idx="1">
+            <a:schemeClr val="accent1"/>
+          </a:lnRef>
+          <a:fillRef idx="3">
+            <a:schemeClr val="accent1"/>
+          </a:fillRef>
+          <a:effectRef idx="2">
+            <a:schemeClr val="accent1"/>
+          </a:effectRef>
+          <a:fontRef idx="minor">
+            <a:schemeClr val="lt1"/>
+          </a:fontRef>
+        </p:style>
+        <p:txBody>
+          <a:bodyPr rtlCol="0" anchor="ctr"/>
+          <a:lstStyle/>
+          <a:p>
+            <a:pPr algn="ctr"/>
+          </a:p>
+        </p:txBody>
+      </p:sp>
+      <p:pic>
+        <p:nvPicPr>
+          <p:cNvPr id="7" name="Picture 6" descr="QR_CungCo_Bai2_Toan10.png"/>
+          <p:cNvPicPr>
+            <a:picLocks noChangeAspect="1"/>
+          </p:cNvPicPr>
+          <p:nvPr/>
+        </p:nvPicPr>
+        <p:blipFill>
+          <a:blip r:embed="rId2"/>
+          <a:stretch>
+            <a:fillRect/>
+          </a:stretch>
+        </p:blipFill>
+        <p:spPr>
+          <a:xfrm>
+            <a:off x="960120" y="1691640"/>
+            <a:ext cx="4114800" cy="4114800"/>
+          </a:xfrm>
+          <a:prstGeom prst="rect">
+            <a:avLst/>
+          </a:prstGeom>
+        </p:spPr>
+      </p:pic>
+      <p:sp>
+        <p:nvSpPr>
+          <p:cNvPr id="8" name="TextBox 7"/>
           <p:cNvSpPr txBox="1"/>
           <p:nvPr/>
         </p:nvSpPr>
         <p:spPr>
           <a:xfrm>
-            <a:off x="731520" y="1508760"/>
-            <a:ext cx="10789920" cy="2267712"/>
+            <a:off x="5760720" y="1554480"/>
+            <a:ext cx="6035040" cy="3108960"/>
           </a:xfrm>
           <a:prstGeom prst="rect">
             <a:avLst/>
@@ -9275,22 +9816,6 @@
             <a:spAutoFit/>
           </a:bodyPr>
           <a:lstStyle/>
-          <a:p>
-            <a:pPr algn="l">
-              <a:spcAft>
-                <a:spcPts val="1000"/>
-              </a:spcAft>
-            </a:pPr>
-            <a:r>
-              <a:rPr sz="2400" b="1">
-                <a:solidFill>
-                  <a:srgbClr val="1E40AF"/>
-                </a:solidFill>
-                <a:latin typeface="Calibri"/>
-              </a:rPr>
-              <a:t>D = {n ∈ ℕ | n nguyên tố, 5 &lt; n &lt; 20}</a:t>
-            </a:r>
-          </a:p>
           <a:p>
             <a:pPr algn="l" marL="365760" indent="-365760">
               <a:spcAft>
@@ -9303,13 +9828,13 @@
               <a:buChar char="•"/>
             </a:pPr>
             <a:r>
-              <a:rPr sz="2400">
+              <a:rPr sz="2600">
                 <a:solidFill>
                   <a:srgbClr val="1E293B"/>
                 </a:solidFill>
                 <a:latin typeface="Calibri"/>
               </a:rPr>
-              <a:t>D = {7; 11; 13; 17; 19}</a:t>
+              <a:t>Quét mã QR bằng điện thoại</a:t>
             </a:r>
           </a:p>
           <a:p>
@@ -9324,13 +9849,13 @@
               <a:buChar char="•"/>
             </a:pPr>
             <a:r>
-              <a:rPr sz="2400">
+              <a:rPr sz="2600">
                 <a:solidFill>
                   <a:srgbClr val="1E293B"/>
                 </a:solidFill>
                 <a:latin typeface="Calibri"/>
               </a:rPr>
-              <a:t>n(D) = 5</a:t>
+              <a:t>Nhập họ tên và lớp</a:t>
             </a:r>
           </a:p>
           <a:p>
@@ -9345,13 +9870,74 @@
               <a:buChar char="•"/>
             </a:pPr>
             <a:r>
-              <a:rPr sz="2400">
+              <a:rPr sz="2600">
                 <a:solidFill>
                   <a:srgbClr val="1E293B"/>
                 </a:solidFill>
                 <a:latin typeface="Calibri"/>
               </a:rPr>
-              <a:t>17 ∈ D;   5 ∉ D;   12 ∉ D;   18 ∉ D</a:t>
+              <a:t>7 câu – làm trong 7 phút</a:t>
+            </a:r>
+          </a:p>
+          <a:p>
+            <a:pPr algn="l" marL="365760" indent="-365760">
+              <a:spcAft>
+                <a:spcPts val="1000"/>
+              </a:spcAft>
+              <a:buClr>
+                <a:srgbClr val="1E40AF"/>
+              </a:buClr>
+              <a:buFont typeface="Arial"/>
+              <a:buChar char="•"/>
+            </a:pPr>
+            <a:r>
+              <a:rPr sz="2600">
+                <a:solidFill>
+                  <a:srgbClr val="1E293B"/>
+                </a:solidFill>
+                <a:latin typeface="Calibri"/>
+              </a:rPr>
+              <a:t>Nộp bài, xem lời giải</a:t>
+            </a:r>
+          </a:p>
+        </p:txBody>
+      </p:sp>
+      <p:sp>
+        <p:nvSpPr>
+          <p:cNvPr id="9" name="TextBox 8"/>
+          <p:cNvSpPr txBox="1"/>
+          <p:nvPr/>
+        </p:nvSpPr>
+        <p:spPr>
+          <a:xfrm>
+            <a:off x="5760720" y="4754880"/>
+            <a:ext cx="6035040" cy="1188720"/>
+          </a:xfrm>
+          <a:prstGeom prst="rect">
+            <a:avLst/>
+          </a:prstGeom>
+          <a:noFill/>
+        </p:spPr>
+        <p:txBody>
+          <a:bodyPr wrap="square" anchor="t">
+            <a:spAutoFit/>
+          </a:bodyPr>
+          <a:lstStyle/>
+          <a:p>
+            <a:pPr algn="l">
+              <a:spcAft>
+                <a:spcPts val="1000"/>
+              </a:spcAft>
+            </a:pPr>
+            <a:r>
+              <a:rPr sz="1800" b="1">
+                <a:solidFill>
+                  <a:srgbClr val="1E40AF"/>
+                </a:solidFill>
+                <a:latin typeface="Calibri"/>
+                <a:hlinkClick r:id="rId3"/>
+              </a:rPr>
+              <a:t>trangtu66.github.io/Taode_thi_online/cc_bai2_t10.html</a:t>
             </a:r>
           </a:p>
         </p:txBody>
@@ -10171,7 +10757,7 @@
         <p:spPr>
           <a:xfrm>
             <a:off x="731520" y="274320"/>
-            <a:ext cx="10972800" cy="868680"/>
+            <a:ext cx="9848088" cy="868680"/>
           </a:xfrm>
           <a:prstGeom prst="rect">
             <a:avLst/>
@@ -10378,6 +10964,59 @@
                 <a:latin typeface="Calibri"/>
               </a:rPr>
               <a:t>c) Điền ∈, ∉: 17, 5, 12, 18 … D</a:t>
+            </a:r>
+          </a:p>
+        </p:txBody>
+      </p:sp>
+      <p:sp>
+        <p:nvSpPr>
+          <p:cNvPr id="7" name="Rounded Rectangle 6"/>
+          <p:cNvSpPr/>
+          <p:nvPr/>
+        </p:nvSpPr>
+        <p:spPr>
+          <a:xfrm>
+            <a:off x="10701223" y="457200"/>
+            <a:ext cx="941832" cy="457200"/>
+          </a:xfrm>
+          <a:prstGeom prst="roundRect">
+            <a:avLst/>
+          </a:prstGeom>
+          <a:solidFill>
+            <a:srgbClr val="1E40AF"/>
+          </a:solidFill>
+          <a:ln>
+            <a:noFill/>
+          </a:ln>
+          <a:effectLst/>
+        </p:spPr>
+        <p:style>
+          <a:lnRef idx="1">
+            <a:schemeClr val="accent1"/>
+          </a:lnRef>
+          <a:fillRef idx="3">
+            <a:schemeClr val="accent1"/>
+          </a:fillRef>
+          <a:effectRef idx="2">
+            <a:schemeClr val="accent1"/>
+          </a:effectRef>
+          <a:fontRef idx="minor">
+            <a:schemeClr val="lt1"/>
+          </a:fontRef>
+        </p:style>
+        <p:txBody>
+          <a:bodyPr rtlCol="0" anchor="ctr" tIns="0" bIns="0"/>
+          <a:lstStyle/>
+          <a:p>
+            <a:pPr algn="ctr"/>
+            <a:r>
+              <a:rPr sz="1400" b="1">
+                <a:solidFill>
+                  <a:srgbClr val="FFFFFF"/>
+                </a:solidFill>
+                <a:latin typeface="Arial"/>
+              </a:rPr>
+              <a:t>ĐỀ BÀI</a:t>
             </a:r>
           </a:p>
         </p:txBody>
@@ -10461,7 +11100,7 @@
         <p:spPr>
           <a:xfrm>
             <a:off x="731520" y="274320"/>
-            <a:ext cx="10972800" cy="868680"/>
+            <a:ext cx="9610344" cy="868680"/>
           </a:xfrm>
           <a:prstGeom prst="rect">
             <a:avLst/>
@@ -10481,7 +11120,7 @@
                 </a:solidFill>
                 <a:latin typeface="Arial"/>
               </a:rPr>
-              <a:t>2. TẬP CON – BIỂU ĐỒ VEN</a:t>
+              <a:t>VÍ DỤ 1</a:t>
             </a:r>
           </a:p>
         </p:txBody>
@@ -10560,7 +11199,7 @@
                 </a:solidFill>
                 <a:latin typeface="Calibri"/>
               </a:rPr>
-              <a:t>Toán 10 · Bài 2. Tập hợp và các phép toán trên tập hợp          7</a:t>
+              <a:t>Toán 10 · Bài 2. Tập hợp và các phép toán trên tập hợp          6</a:t>
             </a:r>
           </a:p>
         </p:txBody>
@@ -10574,7 +11213,7 @@
         <p:spPr>
           <a:xfrm>
             <a:off x="731520" y="1508760"/>
-            <a:ext cx="6400800" cy="1700784"/>
+            <a:ext cx="10789920" cy="2267712"/>
           </a:xfrm>
           <a:prstGeom prst="rect">
             <a:avLst/>
@@ -10586,6 +11225,22 @@
             <a:spAutoFit/>
           </a:bodyPr>
           <a:lstStyle/>
+          <a:p>
+            <a:pPr algn="l">
+              <a:spcAft>
+                <a:spcPts val="1000"/>
+              </a:spcAft>
+            </a:pPr>
+            <a:r>
+              <a:rPr sz="2400" b="1">
+                <a:solidFill>
+                  <a:srgbClr val="1E40AF"/>
+                </a:solidFill>
+                <a:latin typeface="Calibri"/>
+              </a:rPr>
+              <a:t>D = {n ∈ ℕ | n nguyên tố, 5 &lt; n &lt; 20}</a:t>
+            </a:r>
+          </a:p>
           <a:p>
             <a:pPr algn="l" marL="365760" indent="-365760">
               <a:spcAft>
@@ -10604,7 +11259,7 @@
                 </a:solidFill>
                 <a:latin typeface="Calibri"/>
               </a:rPr>
-              <a:t>Mọi phần tử của T thuộc S</a:t>
+              <a:t>D = {7; 11; 13; 17; 19}</a:t>
             </a:r>
           </a:p>
           <a:p>
@@ -10625,7 +11280,7 @@
                 </a:solidFill>
                 <a:latin typeface="Calibri"/>
               </a:rPr>
-              <a:t>Quy ước: ∅ ⊂ S với mọi S</a:t>
+              <a:t>n(D) = 5</a:t>
             </a:r>
           </a:p>
           <a:p>
@@ -10646,7 +11301,7 @@
                 </a:solidFill>
                 <a:latin typeface="Calibri"/>
               </a:rPr>
-              <a:t>Biểu đồ Ven: đường cong kín</a:t>
+              <a:t>17 ∈ D;   5 ∉ D;   12 ∉ D;   18 ∉ D</a:t>
             </a:r>
           </a:p>
         </p:txBody>
@@ -10659,21 +11314,17 @@
         </p:nvSpPr>
         <p:spPr>
           <a:xfrm>
-            <a:off x="731520" y="3346704"/>
-            <a:ext cx="6400800" cy="685800"/>
+            <a:off x="10463479" y="457200"/>
+            <a:ext cx="1179576" cy="457200"/>
           </a:xfrm>
           <a:prstGeom prst="roundRect">
-            <a:avLst>
-              <a:gd name="adj" fmla="val 8000"/>
-            </a:avLst>
+            <a:avLst/>
           </a:prstGeom>
           <a:solidFill>
-            <a:srgbClr val="FEF2F2"/>
+            <a:srgbClr val="166534"/>
           </a:solidFill>
-          <a:ln w="19050">
-            <a:solidFill>
-              <a:srgbClr val="991B1B"/>
-            </a:solidFill>
+          <a:ln>
+            <a:noFill/>
           </a:ln>
           <a:effectLst/>
         </p:spPr>
@@ -10692,76 +11343,22 @@
           </a:fontRef>
         </p:style>
         <p:txBody>
-          <a:bodyPr rtlCol="0" anchor="ctr"/>
+          <a:bodyPr rtlCol="0" anchor="ctr" tIns="0" bIns="0"/>
           <a:lstStyle/>
           <a:p>
             <a:pPr algn="ctr"/>
-          </a:p>
-        </p:txBody>
-      </p:sp>
-      <p:sp>
-        <p:nvSpPr>
-          <p:cNvPr id="8" name="TextBox 7"/>
-          <p:cNvSpPr txBox="1"/>
-          <p:nvPr/>
-        </p:nvSpPr>
-        <p:spPr>
-          <a:xfrm>
-            <a:off x="914400" y="3346704"/>
-            <a:ext cx="6035040" cy="685800"/>
-          </a:xfrm>
-          <a:prstGeom prst="rect">
-            <a:avLst/>
-          </a:prstGeom>
-          <a:noFill/>
-        </p:spPr>
-        <p:txBody>
-          <a:bodyPr wrap="square" anchor="ctr">
-            <a:spAutoFit/>
-          </a:bodyPr>
-          <a:lstStyle/>
-          <a:p>
-            <a:pPr algn="l">
-              <a:spcAft>
-                <a:spcPts val="400"/>
-              </a:spcAft>
-            </a:pPr>
-            <a:r>
-              <a:rPr sz="2400" b="1">
-                <a:solidFill>
-                  <a:srgbClr val="991B1B"/>
-                </a:solidFill>
-                <a:latin typeface="Calibri"/>
-              </a:rPr>
-              <a:t>T ⊂ S ⇔ ∀x, x ∈ T ⇒ x ∈ S</a:t>
-            </a:r>
-          </a:p>
-        </p:txBody>
-      </p:sp>
-      <p:pic>
-        <p:nvPicPr>
-          <p:cNvPr id="9" name="Picture 8" descr="rId10.png"/>
-          <p:cNvPicPr>
-            <a:picLocks noChangeAspect="1"/>
-          </p:cNvPicPr>
-          <p:nvPr/>
-        </p:nvPicPr>
-        <p:blipFill>
-          <a:blip r:embed="rId2"/>
-          <a:stretch>
-            <a:fillRect/>
-          </a:stretch>
-        </p:blipFill>
-        <p:spPr>
-          <a:xfrm>
-            <a:off x="8033050" y="1463040"/>
-            <a:ext cx="3136300" cy="4709160"/>
-          </a:xfrm>
-          <a:prstGeom prst="rect">
-            <a:avLst/>
-          </a:prstGeom>
-        </p:spPr>
-      </p:pic>
+            <a:r>
+              <a:rPr sz="1400" b="1">
+                <a:solidFill>
+                  <a:srgbClr val="FFFFFF"/>
+                </a:solidFill>
+                <a:latin typeface="Arial"/>
+              </a:rPr>
+              <a:t>LỜI GIẢI</a:t>
+            </a:r>
+          </a:p>
+        </p:txBody>
+      </p:sp>
     </p:spTree>
   </p:cSld>
   <p:clrMapOvr>
@@ -10861,7 +11458,7 @@
                 </a:solidFill>
                 <a:latin typeface="Arial"/>
               </a:rPr>
-              <a:t>VÍ DỤ 2: TẬP CON CỦA S = {2; 3; 5}</a:t>
+              <a:t>2. TẬP CON – BIỂU ĐỒ VEN</a:t>
             </a:r>
           </a:p>
         </p:txBody>
@@ -10940,7 +11537,7 @@
                 </a:solidFill>
                 <a:latin typeface="Calibri"/>
               </a:rPr>
-              <a:t>Toán 10 · Bài 2. Tập hợp và các phép toán trên tập hợp          8</a:t>
+              <a:t>Toán 10 · Bài 2. Tập hợp và các phép toán trên tập hợp          7</a:t>
             </a:r>
           </a:p>
         </p:txBody>
@@ -10954,7 +11551,7 @@
         <p:spPr>
           <a:xfrm>
             <a:off x="731520" y="1508760"/>
-            <a:ext cx="10789920" cy="2267712"/>
+            <a:ext cx="6400800" cy="1700784"/>
           </a:xfrm>
           <a:prstGeom prst="rect">
             <a:avLst/>
@@ -10984,7 +11581,7 @@
                 </a:solidFill>
                 <a:latin typeface="Calibri"/>
               </a:rPr>
-              <a:t>Cho S = {2; 3; 5}</a:t>
+              <a:t>Mọi phần tử của T thuộc S</a:t>
             </a:r>
           </a:p>
           <a:p>
@@ -11005,7 +11602,7 @@
                 </a:solidFill>
                 <a:latin typeface="Calibri"/>
               </a:rPr>
-              <a:t>S₁ = {3};  S₂ = {0; 2};  S₃ = {3; 5}</a:t>
+              <a:t>Quy ước: ∅ ⊂ S với mọi S</a:t>
             </a:r>
           </a:p>
           <a:p>
@@ -11026,27 +11623,122 @@
                 </a:solidFill>
                 <a:latin typeface="Calibri"/>
               </a:rPr>
-              <a:t>Tập nào là tập con của S?</a:t>
-            </a:r>
-          </a:p>
+              <a:t>Biểu đồ Ven: đường cong kín</a:t>
+            </a:r>
+          </a:p>
+        </p:txBody>
+      </p:sp>
+      <p:sp>
+        <p:nvSpPr>
+          <p:cNvPr id="7" name="Rounded Rectangle 6"/>
+          <p:cNvSpPr/>
+          <p:nvPr/>
+        </p:nvSpPr>
+        <p:spPr>
+          <a:xfrm>
+            <a:off x="731520" y="3346704"/>
+            <a:ext cx="6400800" cy="685800"/>
+          </a:xfrm>
+          <a:prstGeom prst="roundRect">
+            <a:avLst>
+              <a:gd name="adj" fmla="val 8000"/>
+            </a:avLst>
+          </a:prstGeom>
+          <a:solidFill>
+            <a:srgbClr val="FEF2F2"/>
+          </a:solidFill>
+          <a:ln w="19050">
+            <a:solidFill>
+              <a:srgbClr val="991B1B"/>
+            </a:solidFill>
+          </a:ln>
+          <a:effectLst/>
+        </p:spPr>
+        <p:style>
+          <a:lnRef idx="1">
+            <a:schemeClr val="accent1"/>
+          </a:lnRef>
+          <a:fillRef idx="3">
+            <a:schemeClr val="accent1"/>
+          </a:fillRef>
+          <a:effectRef idx="2">
+            <a:schemeClr val="accent1"/>
+          </a:effectRef>
+          <a:fontRef idx="minor">
+            <a:schemeClr val="lt1"/>
+          </a:fontRef>
+        </p:style>
+        <p:txBody>
+          <a:bodyPr rtlCol="0" anchor="ctr"/>
+          <a:lstStyle/>
+          <a:p>
+            <a:pPr algn="ctr"/>
+          </a:p>
+        </p:txBody>
+      </p:sp>
+      <p:sp>
+        <p:nvSpPr>
+          <p:cNvPr id="8" name="TextBox 7"/>
+          <p:cNvSpPr txBox="1"/>
+          <p:nvPr/>
+        </p:nvSpPr>
+        <p:spPr>
+          <a:xfrm>
+            <a:off x="914400" y="3346704"/>
+            <a:ext cx="6035040" cy="685800"/>
+          </a:xfrm>
+          <a:prstGeom prst="rect">
+            <a:avLst/>
+          </a:prstGeom>
+          <a:noFill/>
+        </p:spPr>
+        <p:txBody>
+          <a:bodyPr wrap="square" anchor="ctr">
+            <a:spAutoFit/>
+          </a:bodyPr>
+          <a:lstStyle/>
           <a:p>
             <a:pPr algn="l">
               <a:spcAft>
-                <a:spcPts val="1000"/>
+                <a:spcPts val="400"/>
               </a:spcAft>
             </a:pPr>
             <a:r>
               <a:rPr sz="2400" b="1">
                 <a:solidFill>
-                  <a:srgbClr val="1E40AF"/>
-                </a:solidFill>
-                <a:latin typeface="Calibri"/>
-              </a:rPr>
-              <a:t>Gợi mở: Mọi phần tử có thuộc S?</a:t>
-            </a:r>
-          </a:p>
-        </p:txBody>
-      </p:sp>
+                  <a:srgbClr val="991B1B"/>
+                </a:solidFill>
+                <a:latin typeface="Calibri"/>
+              </a:rPr>
+              <a:t>T ⊂ S ⇔ ∀x, x ∈ T ⇒ x ∈ S</a:t>
+            </a:r>
+          </a:p>
+        </p:txBody>
+      </p:sp>
+      <p:pic>
+        <p:nvPicPr>
+          <p:cNvPr id="9" name="Picture 8" descr="rId10.png"/>
+          <p:cNvPicPr>
+            <a:picLocks noChangeAspect="1"/>
+          </p:cNvPicPr>
+          <p:nvPr/>
+        </p:nvPicPr>
+        <p:blipFill>
+          <a:blip r:embed="rId2"/>
+          <a:stretch>
+            <a:fillRect/>
+          </a:stretch>
+        </p:blipFill>
+        <p:spPr>
+          <a:xfrm>
+            <a:off x="8033050" y="1463040"/>
+            <a:ext cx="3136300" cy="4709160"/>
+          </a:xfrm>
+          <a:prstGeom prst="rect">
+            <a:avLst/>
+          </a:prstGeom>
+        </p:spPr>
+      </p:pic>
     </p:spTree>
   </p:cSld>
   <p:clrMapOvr>
@@ -11126,7 +11818,7 @@
         <p:spPr>
           <a:xfrm>
             <a:off x="731520" y="274320"/>
-            <a:ext cx="10972800" cy="868680"/>
+            <a:ext cx="9848088" cy="868680"/>
           </a:xfrm>
           <a:prstGeom prst="rect">
             <a:avLst/>
@@ -11146,7 +11838,7 @@
                 </a:solidFill>
                 <a:latin typeface="Arial"/>
               </a:rPr>
-              <a:t>HAI TẬP HỢP BẰNG NHAU</a:t>
+              <a:t>VÍ DỤ 2: TẬP CON CỦA S = {2; 3; 5}</a:t>
             </a:r>
           </a:p>
         </p:txBody>
@@ -11225,7 +11917,7 @@
                 </a:solidFill>
                 <a:latin typeface="Calibri"/>
               </a:rPr>
-              <a:t>Toán 10 · Bài 2. Tập hợp và các phép toán trên tập hợp          10</a:t>
+              <a:t>Toán 10 · Bài 2. Tập hợp và các phép toán trên tập hợp          8</a:t>
             </a:r>
           </a:p>
         </p:txBody>
@@ -11251,22 +11943,6 @@
             <a:spAutoFit/>
           </a:bodyPr>
           <a:lstStyle/>
-          <a:p>
-            <a:pPr algn="l">
-              <a:spcAft>
-                <a:spcPts val="1000"/>
-              </a:spcAft>
-            </a:pPr>
-            <a:r>
-              <a:rPr sz="2400" b="1">
-                <a:solidFill>
-                  <a:srgbClr val="1E40AF"/>
-                </a:solidFill>
-                <a:latin typeface="Calibri"/>
-              </a:rPr>
-              <a:t>Hai tập có cùng các phần tử</a:t>
-            </a:r>
-          </a:p>
           <a:p>
             <a:pPr algn="l" marL="365760" indent="-365760">
               <a:spcAft>
@@ -11285,7 +11961,7 @@
                 </a:solidFill>
                 <a:latin typeface="Calibri"/>
               </a:rPr>
-              <a:t>C: bội chung của 2 và 3, nhỏ hơn 30</a:t>
+              <a:t>Cho S = {2; 3; 5}</a:t>
             </a:r>
           </a:p>
           <a:p>
@@ -11306,7 +11982,7 @@
                 </a:solidFill>
                 <a:latin typeface="Calibri"/>
               </a:rPr>
-              <a:t>D: bội của 6, nhỏ hơn 30</a:t>
+              <a:t>S₁ = {3};  S₂ = {0; 2};  S₃ = {3; 5}</a:t>
             </a:r>
           </a:p>
           <a:p>
@@ -11327,7 +12003,23 @@
                 </a:solidFill>
                 <a:latin typeface="Calibri"/>
               </a:rPr>
-              <a:t>C = D = {0; 6; 12; 18; 24}</a:t>
+              <a:t>Tập nào là tập con của S?</a:t>
+            </a:r>
+          </a:p>
+          <a:p>
+            <a:pPr algn="l">
+              <a:spcAft>
+                <a:spcPts val="1000"/>
+              </a:spcAft>
+            </a:pPr>
+            <a:r>
+              <a:rPr sz="2400" b="1">
+                <a:solidFill>
+                  <a:srgbClr val="1E40AF"/>
+                </a:solidFill>
+                <a:latin typeface="Calibri"/>
+              </a:rPr>
+              <a:t>Gợi mở: Mọi phần tử có thuộc S?</a:t>
             </a:r>
           </a:p>
         </p:txBody>
@@ -11340,21 +12032,17 @@
         </p:nvSpPr>
         <p:spPr>
           <a:xfrm>
-            <a:off x="731520" y="3913632"/>
-            <a:ext cx="8686800" cy="685800"/>
+            <a:off x="10701223" y="457200"/>
+            <a:ext cx="941832" cy="457200"/>
           </a:xfrm>
           <a:prstGeom prst="roundRect">
-            <a:avLst>
-              <a:gd name="adj" fmla="val 8000"/>
-            </a:avLst>
+            <a:avLst/>
           </a:prstGeom>
           <a:solidFill>
-            <a:srgbClr val="FEF2F2"/>
+            <a:srgbClr val="1E40AF"/>
           </a:solidFill>
-          <a:ln w="19050">
-            <a:solidFill>
-              <a:srgbClr val="991B1B"/>
-            </a:solidFill>
+          <a:ln>
+            <a:noFill/>
           </a:ln>
           <a:effectLst/>
         </p:spPr>
@@ -11373,48 +12061,18 @@
           </a:fontRef>
         </p:style>
         <p:txBody>
-          <a:bodyPr rtlCol="0" anchor="ctr"/>
+          <a:bodyPr rtlCol="0" anchor="ctr" tIns="0" bIns="0"/>
           <a:lstStyle/>
           <a:p>
             <a:pPr algn="ctr"/>
-          </a:p>
-        </p:txBody>
-      </p:sp>
-      <p:sp>
-        <p:nvSpPr>
-          <p:cNvPr id="8" name="TextBox 7"/>
-          <p:cNvSpPr txBox="1"/>
-          <p:nvPr/>
-        </p:nvSpPr>
-        <p:spPr>
-          <a:xfrm>
-            <a:off x="914400" y="3913632"/>
-            <a:ext cx="8321040" cy="685800"/>
-          </a:xfrm>
-          <a:prstGeom prst="rect">
-            <a:avLst/>
-          </a:prstGeom>
-          <a:noFill/>
-        </p:spPr>
-        <p:txBody>
-          <a:bodyPr wrap="square" anchor="ctr">
-            <a:spAutoFit/>
-          </a:bodyPr>
-          <a:lstStyle/>
-          <a:p>
-            <a:pPr algn="l">
-              <a:spcAft>
-                <a:spcPts val="400"/>
-              </a:spcAft>
-            </a:pPr>
-            <a:r>
-              <a:rPr sz="2400" b="1">
-                <a:solidFill>
-                  <a:srgbClr val="991B1B"/>
-                </a:solidFill>
-                <a:latin typeface="Calibri"/>
-              </a:rPr>
-              <a:t>S ⊂ T và T ⊂ S  ⇒  S = T</a:t>
+            <a:r>
+              <a:rPr sz="1400" b="1">
+                <a:solidFill>
+                  <a:srgbClr val="FFFFFF"/>
+                </a:solidFill>
+                <a:latin typeface="Arial"/>
+              </a:rPr>
+              <a:t>ĐỀ BÀI</a:t>
             </a:r>
           </a:p>
         </p:txBody>
@@ -11498,7 +12156,7 @@
         <p:spPr>
           <a:xfrm>
             <a:off x="731520" y="274320"/>
-            <a:ext cx="10972800" cy="868680"/>
+            <a:ext cx="9610344" cy="868680"/>
           </a:xfrm>
           <a:prstGeom prst="rect">
             <a:avLst/>
@@ -11518,7 +12176,7 @@
                 </a:solidFill>
                 <a:latin typeface="Arial"/>
               </a:rPr>
-              <a:t>3. CÁC TẬP HỢP SỐ</a:t>
+              <a:t>VÍ DỤ 2: TẬP CON CỦA S = {2; 3; 5}</a:t>
             </a:r>
           </a:p>
         </p:txBody>
@@ -11597,7 +12255,7 @@
                 </a:solidFill>
                 <a:latin typeface="Calibri"/>
               </a:rPr>
-              <a:t>Toán 10 · Bài 2. Tập hợp và các phép toán trên tập hợp          11</a:t>
+              <a:t>Toán 10 · Bài 2. Tập hợp và các phép toán trên tập hợp          9</a:t>
             </a:r>
           </a:p>
         </p:txBody>
@@ -11611,7 +12269,7 @@
         <p:spPr>
           <a:xfrm>
             <a:off x="731520" y="1508760"/>
-            <a:ext cx="6400800" cy="2267712"/>
+            <a:ext cx="10789920" cy="1133856"/>
           </a:xfrm>
           <a:prstGeom prst="rect">
             <a:avLst/>
@@ -11641,7 +12299,43 @@
                 </a:solidFill>
                 <a:latin typeface="Calibri"/>
               </a:rPr>
-              <a:t>ℕ: số tự nhiên;  ℤ: số nguyên</a:t>
+              <a:t>S</a:t>
+            </a:r>
+            <a:r>
+              <a:rPr sz="2400" baseline="-25000">
+                <a:solidFill>
+                  <a:srgbClr val="1E293B"/>
+                </a:solidFill>
+                <a:latin typeface="Calibri"/>
+              </a:rPr>
+              <a:t>1</a:t>
+            </a:r>
+            <a:r>
+              <a:rPr sz="2400">
+                <a:solidFill>
+                  <a:srgbClr val="1E293B"/>
+                </a:solidFill>
+                <a:latin typeface="Calibri"/>
+              </a:rPr>
+              <a:t> = {3} ⊂ S;   S</a:t>
+            </a:r>
+            <a:r>
+              <a:rPr sz="2400" baseline="-25000">
+                <a:solidFill>
+                  <a:srgbClr val="1E293B"/>
+                </a:solidFill>
+                <a:latin typeface="Calibri"/>
+              </a:rPr>
+              <a:t>3</a:t>
+            </a:r>
+            <a:r>
+              <a:rPr sz="2400">
+                <a:solidFill>
+                  <a:srgbClr val="1E293B"/>
+                </a:solidFill>
+                <a:latin typeface="Calibri"/>
+              </a:rPr>
+              <a:t> = {3; 5} ⊂ S</a:t>
             </a:r>
           </a:p>
           <a:p>
@@ -11662,20 +12356,17 @@
                 </a:solidFill>
                 <a:latin typeface="Calibri"/>
               </a:rPr>
-              <a:t>ℚ: số viết được dạng a/b</a:t>
-            </a:r>
-          </a:p>
-          <a:p>
-            <a:pPr algn="l" marL="365760" indent="-365760">
-              <a:spcAft>
-                <a:spcPts val="1000"/>
-              </a:spcAft>
-              <a:buClr>
-                <a:srgbClr val="1E40AF"/>
-              </a:buClr>
-              <a:buFont typeface="Arial"/>
-              <a:buChar char="•"/>
-            </a:pPr>
+              <a:t>S</a:t>
+            </a:r>
+            <a:r>
+              <a:rPr sz="2400" baseline="-25000">
+                <a:solidFill>
+                  <a:srgbClr val="1E293B"/>
+                </a:solidFill>
+                <a:latin typeface="Calibri"/>
+              </a:rPr>
+              <a:t>2</a:t>
+            </a:r>
             <a:r>
               <a:rPr sz="2400">
                 <a:solidFill>
@@ -11683,122 +12374,14 @@
                 </a:solidFill>
                 <a:latin typeface="Calibri"/>
               </a:rPr>
-              <a:t>ℝ: gồm số hữu tỉ và vô tỉ</a:t>
-            </a:r>
-          </a:p>
-          <a:p>
-            <a:pPr algn="l" marL="365760" indent="-365760">
-              <a:spcAft>
-                <a:spcPts val="1000"/>
-              </a:spcAft>
-              <a:buClr>
-                <a:srgbClr val="1E40AF"/>
-              </a:buClr>
-              <a:buFont typeface="Arial"/>
-              <a:buChar char="•"/>
-            </a:pPr>
-            <a:r>
-              <a:rPr sz="2400">
-                <a:solidFill>
-                  <a:srgbClr val="1E293B"/>
-                </a:solidFill>
-                <a:latin typeface="Calibri"/>
-              </a:rPr>
-              <a:t>√2 ∈ ℝ nhưng √2 ∉ ℚ</a:t>
-            </a:r>
-          </a:p>
-        </p:txBody>
-      </p:sp>
-      <p:sp>
-        <p:nvSpPr>
-          <p:cNvPr id="7" name="Rounded Rectangle 6"/>
-          <p:cNvSpPr/>
-          <p:nvPr/>
-        </p:nvSpPr>
-        <p:spPr>
-          <a:xfrm>
-            <a:off x="731520" y="3913632"/>
-            <a:ext cx="6400800" cy="685800"/>
-          </a:xfrm>
-          <a:prstGeom prst="roundRect">
-            <a:avLst>
-              <a:gd name="adj" fmla="val 8000"/>
-            </a:avLst>
-          </a:prstGeom>
-          <a:solidFill>
-            <a:srgbClr val="FEF2F2"/>
-          </a:solidFill>
-          <a:ln w="19050">
-            <a:solidFill>
-              <a:srgbClr val="991B1B"/>
-            </a:solidFill>
-          </a:ln>
-          <a:effectLst/>
-        </p:spPr>
-        <p:style>
-          <a:lnRef idx="1">
-            <a:schemeClr val="accent1"/>
-          </a:lnRef>
-          <a:fillRef idx="3">
-            <a:schemeClr val="accent1"/>
-          </a:fillRef>
-          <a:effectRef idx="2">
-            <a:schemeClr val="accent1"/>
-          </a:effectRef>
-          <a:fontRef idx="minor">
-            <a:schemeClr val="lt1"/>
-          </a:fontRef>
-        </p:style>
-        <p:txBody>
-          <a:bodyPr rtlCol="0" anchor="ctr"/>
-          <a:lstStyle/>
-          <a:p>
-            <a:pPr algn="ctr"/>
-          </a:p>
-        </p:txBody>
-      </p:sp>
-      <p:sp>
-        <p:nvSpPr>
-          <p:cNvPr id="8" name="TextBox 7"/>
-          <p:cNvSpPr txBox="1"/>
-          <p:nvPr/>
-        </p:nvSpPr>
-        <p:spPr>
-          <a:xfrm>
-            <a:off x="914400" y="3913632"/>
-            <a:ext cx="6035040" cy="685800"/>
-          </a:xfrm>
-          <a:prstGeom prst="rect">
-            <a:avLst/>
-          </a:prstGeom>
-          <a:noFill/>
-        </p:spPr>
-        <p:txBody>
-          <a:bodyPr wrap="square" anchor="ctr">
-            <a:spAutoFit/>
-          </a:bodyPr>
-          <a:lstStyle/>
-          <a:p>
-            <a:pPr algn="l">
-              <a:spcAft>
-                <a:spcPts val="400"/>
-              </a:spcAft>
-            </a:pPr>
-            <a:r>
-              <a:rPr sz="2400" b="1">
-                <a:solidFill>
-                  <a:srgbClr val="991B1B"/>
-                </a:solidFill>
-                <a:latin typeface="Calibri"/>
-              </a:rPr>
-              <a:t>ℕ ⊂ ℤ ⊂ ℚ ⊂ ℝ</a:t>
+              <a:t> = {0; 2} ⊄ S vì 0 ∉ S</a:t>
             </a:r>
           </a:p>
         </p:txBody>
       </p:sp>
       <p:pic>
         <p:nvPicPr>
-          <p:cNvPr id="9" name="Picture 8" descr="rId12.png"/>
+          <p:cNvPr id="7" name="Picture 6" descr="rId11.png"/>
           <p:cNvPicPr>
             <a:picLocks noChangeAspect="1"/>
           </p:cNvPicPr>
@@ -11812,14 +12395,67 @@
         </p:blipFill>
         <p:spPr>
           <a:xfrm>
-            <a:off x="7406640" y="1770380"/>
-            <a:ext cx="4389120" cy="4094480"/>
+            <a:off x="1065576" y="2779776"/>
+            <a:ext cx="10030368" cy="3438144"/>
           </a:xfrm>
           <a:prstGeom prst="rect">
             <a:avLst/>
           </a:prstGeom>
         </p:spPr>
       </p:pic>
+      <p:sp>
+        <p:nvSpPr>
+          <p:cNvPr id="8" name="Rounded Rectangle 7"/>
+          <p:cNvSpPr/>
+          <p:nvPr/>
+        </p:nvSpPr>
+        <p:spPr>
+          <a:xfrm>
+            <a:off x="10463479" y="457200"/>
+            <a:ext cx="1179576" cy="457200"/>
+          </a:xfrm>
+          <a:prstGeom prst="roundRect">
+            <a:avLst/>
+          </a:prstGeom>
+          <a:solidFill>
+            <a:srgbClr val="166534"/>
+          </a:solidFill>
+          <a:ln>
+            <a:noFill/>
+          </a:ln>
+          <a:effectLst/>
+        </p:spPr>
+        <p:style>
+          <a:lnRef idx="1">
+            <a:schemeClr val="accent1"/>
+          </a:lnRef>
+          <a:fillRef idx="3">
+            <a:schemeClr val="accent1"/>
+          </a:fillRef>
+          <a:effectRef idx="2">
+            <a:schemeClr val="accent1"/>
+          </a:effectRef>
+          <a:fontRef idx="minor">
+            <a:schemeClr val="lt1"/>
+          </a:fontRef>
+        </p:style>
+        <p:txBody>
+          <a:bodyPr rtlCol="0" anchor="ctr" tIns="0" bIns="0"/>
+          <a:lstStyle/>
+          <a:p>
+            <a:pPr algn="ctr"/>
+            <a:r>
+              <a:rPr sz="1400" b="1">
+                <a:solidFill>
+                  <a:srgbClr val="FFFFFF"/>
+                </a:solidFill>
+                <a:latin typeface="Arial"/>
+              </a:rPr>
+              <a:t>LỜI GIẢI</a:t>
+            </a:r>
+          </a:p>
+        </p:txBody>
+      </p:sp>
     </p:spTree>
   </p:cSld>
   <p:clrMapOvr>

</xml_diff>